<commit_message>
docs: remove duplicate slide citation layer caught by PDF QA
</commit_message>
<xml_diff>
--- a/research/review_materials/UPI_PROTOTYPE_FACULTY_8_SLIDES.pptx
+++ b/research/review_materials/UPI_PROTOTYPE_FACULTY_8_SLIDES.pptx
@@ -5333,7 +5333,7 @@
                   </a:extLst>
                 </a:hlinkClick>
               </a:rPr>
-              <a:t>prototype source and retained records</a:t>
+              <a:t>source-grounded literature matrix (review branch)</a:t>
             </a:r>
             <a:endParaRPr lang="en-US" sz="1000" dirty="0"/>
           </a:p>
@@ -5633,65 +5633,6 @@
               <a:t>Useful research infrastructure, not a first-ever algorithm or superiority claim.</a:t>
             </a:r>
             <a:endParaRPr lang="en-US" sz="1500" dirty="0"/>
-          </a:p>
-        </p:txBody>
-      </p:sp>
-      <p:sp>
-        <p:nvSpPr>
-          <p:cNvPr id="12" name="Text 10"/>
-          <p:cNvSpPr/>
-          <p:nvPr/>
-        </p:nvSpPr>
-        <p:spPr>
-          <a:xfrm>
-            <a:off x="457200" y="4370832"/>
-            <a:ext cx="8001000" cy="201168"/>
-          </a:xfrm>
-          <a:prstGeom prst="rect">
-            <a:avLst/>
-          </a:prstGeom>
-          <a:solidFill>
-            <a:srgbClr val="FFFFFF"/>
-          </a:solidFill>
-          <a:ln/>
-        </p:spPr>
-        <p:txBody>
-          <a:bodyPr wrap="square" lIns="0" tIns="0" rIns="0" bIns="0" rtlCol="0" anchor="ctr"/>
-          <a:lstStyle/>
-          <a:p>
-            <a:pPr indent="0" marL="0">
-              <a:buNone/>
-            </a:pPr>
-            <a:r>
-              <a:rPr lang="en-US" sz="1000" dirty="0">
-                <a:solidFill>
-                  <a:srgbClr val="465E62"/>
-                </a:solidFill>
-                <a:latin typeface="Arial" pitchFamily="34" charset="0"/>
-                <a:ea typeface="Arial" pitchFamily="34" charset="-122"/>
-                <a:cs typeface="Arial" pitchFamily="34" charset="-120"/>
-              </a:rPr>
-              <a:t>Source: </a:t>
-            </a:r>
-            <a:r>
-              <a:rPr lang="en-US" sz="1000" u="sng" dirty="0">
-                <a:solidFill>
-                  <a:srgbClr val="01696F"/>
-                </a:solidFill>
-                <a:latin typeface="Arial" pitchFamily="34" charset="0"/>
-                <a:ea typeface="Arial" pitchFamily="34" charset="-122"/>
-                <a:cs typeface="Arial" pitchFamily="34" charset="-120"/>
-                <a:hlinkClick r:id="rId2" invalidUrl="" action="" tgtFrame="" tooltip="" history="1" highlightClick="0" endSnd="0">
-                  <a:extLst>
-                    <a:ext uri="{A12FA001-AC4F-418D-AE19-62706E023703}">
-                      <ahyp:hlinkClr xmlns:ahyp="http://schemas.microsoft.com/office/drawing/2018/hyperlinkcolor" val="tx"/>
-                    </a:ext>
-                  </a:extLst>
-                </a:hlinkClick>
-              </a:rPr>
-              <a:t>source-grounded literature matrix (review branch)</a:t>
-            </a:r>
-            <a:endParaRPr lang="en-US" sz="1000" dirty="0"/>
           </a:p>
         </p:txBody>
       </p:sp>

</xml_diff>

<commit_message>
docs: add faculty team and terminal results to final prototype slides
</commit_message>
<xml_diff>
--- a/research/review_materials/UPI_PROTOTYPE_FACULTY_8_SLIDES.pptx
+++ b/research/review_materials/UPI_PROTOTYPE_FACULTY_8_SLIDES.pptx
@@ -148,7 +148,7 @@
           </c:spPr>
           <c:invertIfNegative val="0"/>
           <c:dLbls>
-            <c:numFmt formatCode="0.0" sourceLinked="0"/>
+            <c:numFmt formatCode="0" sourceLinked="0"/>
             <c:txPr>
               <a:bodyPr/>
               <a:lstStyle/>
@@ -236,7 +236,7 @@
           </c:spPr>
           <c:invertIfNegative val="0"/>
           <c:dLbls>
-            <c:numFmt formatCode="0.0" sourceLinked="0"/>
+            <c:numFmt formatCode="0" sourceLinked="0"/>
             <c:txPr>
               <a:bodyPr/>
               <a:lstStyle/>
@@ -303,7 +303,7 @@
           </c:val>
         </c:ser>
         <c:dLbls>
-          <c:numFmt formatCode="0.0" sourceLinked="0"/>
+          <c:numFmt formatCode="0" sourceLinked="0"/>
           <c:txPr>
             <a:bodyPr/>
             <a:lstStyle/>
@@ -900,7 +900,7 @@
           <a:p>
             <a:r>
               <a:rPr lang="en-US" dirty="0"/>
-              <a:t>Lecturer pitch: The project is a Python laboratory, not a deployed fraud-prevention service. It connects attacker decisions, detector responses and simulated account transfers in inspectable campaigns. This presentation describes the requested prototype branch. The later dashboard and matched pilot live on the separate review branch.
+              <a:t>Lecturer pitch: The project is a Python laboratory, not a deployed fraud-prevention service. It connects attacker decisions, detector responses and simulated account transfers in inspectable campaigns. The user selected prototype/rl-academic-complete as the final project branch for this presentation; final selection is not scientific certification. Guide and student names/IDs were supplied by the user. No phone numbers or pasted-chat timestamps are included. The later dashboard and matched pilot live on the separate review branch.
 Repository: https://github.com/YuvakarthikKoduri/Campaign-Level-Adversarial-Stress-Testing-of-UPI-Fraud-Detection-Systems
 Code baseline: 92a12966ec49fd6dcd147fd4d7411382715bc729. Not the later corrected legacy or matched-pilot study.</a:t>
             </a:r>
@@ -1257,7 +1257,7 @@
           <a:p>
             <a:r>
               <a:rPr lang="en-US" dirty="0"/>
-              <a:t>Exact source: prototype_evidence/comparison-final/{campaigns.json,transactions.csv,summary.csv,config.json} at code baseline 92a1296. New read-only arithmetic checked the historical records, not a new full run. Completion is target-reaching campaigns / attempted campaigns. The counts are not the corrected legacy 4,161 transactions or matched pilot 7,200 campaigns. No error bars are plotted; sample seed SD in percentage points in category order Static, Rule, RL, Zero Q:
+              <a:t>Exact source: prototype_evidence/comparison-final/{campaigns.json,transactions.csv,summary.csv,config.json} at code baseline 92a1296. New read-only arithmetic checked the historical records, not a new full run. Completion is target-reaching campaigns / attempted campaigns. Bar labels are rounded to whole percentages to separate adjacent values; the underlying native-chart series retain unrounded values. The counts are not the corrected legacy 4,161 transactions or matched pilot 7,200 campaigns. No error bars are plotted; sample seed SD in percentage points in category order Static, Rule, RL, Zero Q:
 XGBoost: 0.000, 0.000, 0.000, 7.217
 Random Forest: 0.000, 0.000, 2.406, 7.217
 Raw pooled completions: 1077. Pooling is descriptive, not a common strategy effect.
@@ -1349,7 +1349,7 @@
           <a:p>
             <a:r>
               <a:rPr lang="en-US" dirty="0"/>
-              <a:t>The prototype implements an engineering combination, not proven literature-wide novelty. The later source-grounded literature matrix is on review/academic-dashboard-paper-v1 at research/literature_review/comparison_matrix.csv. Published examples include Carminati et al. (RAID 2020), https://www.usenix.org/conference/raid2020/presentation/carminati and Henderson et al., Deep Reinforcement Learning That Matters, https://arxiv.org/abs/1709.06560. No published method is reimplemented on common data here. Inspectable means raw Q state and traces can be examined, not that their correctness is guaranteed.
+              <a:t>The three displayed lines are exact selected lines from previously executed short-main.stdout, not simulated terminal text and not a new experiment in this revision. The original 16-cell run used seed 101, two training episodes per detector and one campaign per detector/kind/attacker cell; all 16 cells completed. Recorded command exit code: 0. See prototype_terminal_excerpt.json for the full output hash, command, selected lines and record hashes. Exposure is the mean gross simulated debit within the cell; here its denominator is one campaign. Static and RL action/amount clipping differ, so the displayed exposure difference does not establish learned superiority or actual savings. The original stderr contains a model portability warning. The full-study counts on slide 5 are separate records.
 Code baseline: 92a12966ec49fd6dcd147fd4d7411382715bc729. Not the later corrected legacy or matched-pilot study.</a:t>
             </a:r>
             <a:endParaRPr lang="en-US" dirty="0"/>
@@ -1527,7 +1527,8 @@
           <a:p>
             <a:r>
               <a:rPr lang="en-US" dirty="0"/>
-              <a:t>Do not promise unseen-fraud detection, a causal adaptation paradox, universal RL superiority, real-world UPI effectiveness, actual victim-loss reduction, zero AI content or an unmeasured similarity threshold. Later audits repaired decimal-money handling, frozen evaluation state and evidence schema checks on the review branch; these repairs are not backported into this documentation-only prototype update. The existing IEEE paper covers that later corrected study and pilot, not this older snapshot alone. University-approved AI-content and similarity reports remain PENDING EXTERNAL VERIFICATION.
+              <a:t>Final is the user's selected delivery branch, not production or scientific-validation certification. Verified comparison: master 1e2ca9e3db4a19bb72e0433f07f10425f74b82fa versus prototype documentation head 25c28300ca738ee2d0a530b99683033668c312ca; research-code baseline 92a12966ec49fd6dcd147fd4d7411382715bc729. Master already contains static/rule attackers, two saved detectors, campaign simulation and scenario JSON reports. Prototype adds src/attackers/q_learning.py, src/experiments/prototype.py, run_prototype.py, saved policies and prototype RL tests. The models/ and data/ trees have zero diff. This comparison is of implementation features, not a controlled performance experiment against master. The prototype branch has no local dashboard; later dashboard, matched pilot and repaired study are on the separate review branch. Historical detector-family exclusion remains unverified and policy comparisons are confounded. Later money, evaluation-state and schema repairs are not backported by this presentation revision. The later IEEE draft remains AI-assisted; human authorship review and university-approved AI-content/similarity checks remain pending. Do not promise a zero AI-content or unmeasured similarity score.
+Prior research already addresses fraud classification, sequential modelling, adversarial evasion and learning-based attackers; the implemented combination is campaign-ledger execution, inspectable tabular policies, checkpoints and traces. No first-ever algorithm or literature-wide novelty claim is made. Literature matrix: https://github.com/YuvakarthikKoduri/Campaign-Level-Adversarial-Stress-Testing-of-UPI-Fraud-Detection-Systems/blob/review/academic-dashboard-paper-v1/research/literature_review/comparison_matrix.csv . Examples: Carminati et al., RAID 2020, https://www.usenix.org/conference/raid2020/presentation/carminati ; Henderson et al., Deep Reinforcement Learning That Matters, https://arxiv.org/abs/1709.06560 .
 Code baseline: 92a12966ec49fd6dcd147fd4d7411382715bc729. Not the later corrected legacy or matched-pilot study.</a:t>
             </a:r>
             <a:endParaRPr lang="en-US" dirty="0"/>
@@ -1910,23 +1911,23 @@
         <p:spPr>
           <a:xfrm>
             <a:off x="548640" y="640080"/>
-            <a:ext cx="8046720" cy="1508760"/>
-          </a:xfrm>
-          <a:prstGeom prst="rect">
-            <a:avLst/>
-          </a:prstGeom>
-          <a:noFill/>
-          <a:ln/>
-        </p:spPr>
-        <p:txBody>
-          <a:bodyPr wrap="square" lIns="0" tIns="0" rIns="0" bIns="0" rtlCol="0" anchor="t"/>
-          <a:lstStyle/>
-          <a:p>
-            <a:pPr indent="0" marL="0">
-              <a:buNone/>
-            </a:pPr>
-            <a:r>
-              <a:rPr lang="en-US" sz="5200" b="1" dirty="0">
+            <a:ext cx="4114800" cy="1508760"/>
+          </a:xfrm>
+          <a:prstGeom prst="rect">
+            <a:avLst/>
+          </a:prstGeom>
+          <a:noFill/>
+          <a:ln/>
+        </p:spPr>
+        <p:txBody>
+          <a:bodyPr wrap="square" lIns="0" tIns="0" rIns="0" bIns="0" rtlCol="0" anchor="t"/>
+          <a:lstStyle/>
+          <a:p>
+            <a:pPr indent="0" marL="0">
+              <a:buNone/>
+            </a:pPr>
+            <a:r>
+              <a:rPr lang="en-US" sz="4600" b="1" dirty="0">
                 <a:solidFill>
                   <a:srgbClr val="FFFFFF"/>
                 </a:solidFill>
@@ -1936,14 +1937,14 @@
               </a:rPr>
               <a:t>UPI Fraud</a:t>
             </a:r>
-            <a:endParaRPr lang="en-US" sz="5200" dirty="0"/>
-          </a:p>
-          <a:p>
-            <a:pPr indent="0" marL="0">
-              <a:buNone/>
-            </a:pPr>
-            <a:r>
-              <a:rPr lang="en-US" sz="5200" b="1" dirty="0">
+            <a:endParaRPr lang="en-US" sz="4600" dirty="0"/>
+          </a:p>
+          <a:p>
+            <a:pPr indent="0" marL="0">
+              <a:buNone/>
+            </a:pPr>
+            <a:r>
+              <a:rPr lang="en-US" sz="4600" b="1" dirty="0">
                 <a:solidFill>
                   <a:srgbClr val="FFFFFF"/>
                 </a:solidFill>
@@ -1953,7 +1954,7 @@
               </a:rPr>
               <a:t>Stress Lab</a:t>
             </a:r>
-            <a:endParaRPr lang="en-US" sz="5200" dirty="0"/>
+            <a:endParaRPr lang="en-US" sz="4600" dirty="0"/>
           </a:p>
         </p:txBody>
       </p:sp>
@@ -1965,24 +1966,24 @@
         </p:nvSpPr>
         <p:spPr>
           <a:xfrm>
-            <a:off x="594360" y="2468880"/>
-            <a:ext cx="7955280" cy="914400"/>
-          </a:xfrm>
-          <a:prstGeom prst="rect">
-            <a:avLst/>
-          </a:prstGeom>
-          <a:noFill/>
-          <a:ln/>
-        </p:spPr>
-        <p:txBody>
-          <a:bodyPr wrap="square" lIns="0" tIns="0" rIns="0" bIns="0" rtlCol="0" anchor="t"/>
-          <a:lstStyle/>
-          <a:p>
-            <a:pPr indent="0" marL="0">
-              <a:buNone/>
-            </a:pPr>
-            <a:r>
-              <a:rPr lang="en-US" sz="2600" dirty="0">
+            <a:off x="594360" y="2423160"/>
+            <a:ext cx="3977640" cy="1097280"/>
+          </a:xfrm>
+          <a:prstGeom prst="rect">
+            <a:avLst/>
+          </a:prstGeom>
+          <a:noFill/>
+          <a:ln/>
+        </p:spPr>
+        <p:txBody>
+          <a:bodyPr wrap="square" lIns="0" tIns="0" rIns="0" bIns="0" rtlCol="0" anchor="t"/>
+          <a:lstStyle/>
+          <a:p>
+            <a:pPr indent="0" marL="0">
+              <a:buNone/>
+            </a:pPr>
+            <a:r>
+              <a:rPr lang="en-US" sz="2300" dirty="0">
                 <a:solidFill>
                   <a:srgbClr val="BCE2E7"/>
                 </a:solidFill>
@@ -1990,16 +1991,16 @@
                 <a:ea typeface="Arial" pitchFamily="34" charset="-122"/>
                 <a:cs typeface="Arial" pitchFamily="34" charset="-120"/>
               </a:rPr>
-              <a:t>Can an attack campaign reach its target</a:t>
-            </a:r>
-            <a:endParaRPr lang="en-US" sz="2600" dirty="0"/>
-          </a:p>
-          <a:p>
-            <a:pPr indent="0" marL="0">
-              <a:buNone/>
-            </a:pPr>
-            <a:r>
-              <a:rPr lang="en-US" sz="2600" dirty="0">
+              <a:t>Can an attack campaign</a:t>
+            </a:r>
+            <a:endParaRPr lang="en-US" sz="2300" dirty="0"/>
+          </a:p>
+          <a:p>
+            <a:pPr indent="0" marL="0">
+              <a:buNone/>
+            </a:pPr>
+            <a:r>
+              <a:rPr lang="en-US" sz="2300" dirty="0">
                 <a:solidFill>
                   <a:srgbClr val="BCE2E7"/>
                 </a:solidFill>
@@ -2007,9 +2008,26 @@
                 <a:ea typeface="Arial" pitchFamily="34" charset="-122"/>
                 <a:cs typeface="Arial" pitchFamily="34" charset="-120"/>
               </a:rPr>
-              <a:t>before a detector stops it?</a:t>
-            </a:r>
-            <a:endParaRPr lang="en-US" sz="2600" dirty="0"/>
+              <a:t>reach its target before a</a:t>
+            </a:r>
+            <a:endParaRPr lang="en-US" sz="2300" dirty="0"/>
+          </a:p>
+          <a:p>
+            <a:pPr indent="0" marL="0">
+              <a:buNone/>
+            </a:pPr>
+            <a:r>
+              <a:rPr lang="en-US" sz="2300" dirty="0">
+                <a:solidFill>
+                  <a:srgbClr val="BCE2E7"/>
+                </a:solidFill>
+                <a:latin typeface="Arial" pitchFamily="34" charset="0"/>
+                <a:ea typeface="Arial" pitchFamily="34" charset="-122"/>
+                <a:cs typeface="Arial" pitchFamily="34" charset="-120"/>
+              </a:rPr>
+              <a:t>detector stops it?</a:t>
+            </a:r>
+            <a:endParaRPr lang="en-US" sz="2300" dirty="0"/>
           </a:p>
         </p:txBody>
       </p:sp>
@@ -2021,24 +2039,24 @@
         </p:nvSpPr>
         <p:spPr>
           <a:xfrm>
-            <a:off x="594360" y="3657600"/>
-            <a:ext cx="7863840" cy="365760"/>
-          </a:xfrm>
-          <a:prstGeom prst="rect">
-            <a:avLst/>
-          </a:prstGeom>
-          <a:noFill/>
-          <a:ln/>
-        </p:spPr>
-        <p:txBody>
-          <a:bodyPr wrap="square" lIns="0" tIns="0" rIns="0" bIns="0" rtlCol="0" anchor="t"/>
-          <a:lstStyle/>
-          <a:p>
-            <a:pPr indent="0" marL="0">
-              <a:buNone/>
-            </a:pPr>
-            <a:r>
-              <a:rPr lang="en-US" sz="1700" dirty="0">
+            <a:off x="594360" y="3703320"/>
+            <a:ext cx="3977640" cy="411480"/>
+          </a:xfrm>
+          <a:prstGeom prst="rect">
+            <a:avLst/>
+          </a:prstGeom>
+          <a:noFill/>
+          <a:ln/>
+        </p:spPr>
+        <p:txBody>
+          <a:bodyPr wrap="square" lIns="0" tIns="0" rIns="0" bIns="0" rtlCol="0" anchor="t"/>
+          <a:lstStyle/>
+          <a:p>
+            <a:pPr indent="0" marL="0">
+              <a:buNone/>
+            </a:pPr>
+            <a:r>
+              <a:rPr lang="en-US" sz="1500" dirty="0">
                 <a:solidFill>
                   <a:srgbClr val="FFFFFF"/>
                 </a:solidFill>
@@ -2046,15 +2064,327 @@
                 <a:ea typeface="Arial" pitchFamily="34" charset="-122"/>
                 <a:cs typeface="Arial" pitchFamily="34" charset="-120"/>
               </a:rPr>
-              <a:t>A working, synthetic campaign-level research prototype</a:t>
-            </a:r>
-            <a:endParaRPr lang="en-US" sz="1700" dirty="0"/>
+              <a:t>A synthetic campaign-level research laboratory</a:t>
+            </a:r>
+            <a:endParaRPr lang="en-US" sz="1500" dirty="0"/>
           </a:p>
         </p:txBody>
       </p:sp>
       <p:sp>
         <p:nvSpPr>
           <p:cNvPr id="5" name="Text 3"/>
+          <p:cNvSpPr/>
+          <p:nvPr/>
+        </p:nvSpPr>
+        <p:spPr>
+          <a:xfrm>
+            <a:off x="4892040" y="731520"/>
+            <a:ext cx="3657600" cy="228600"/>
+          </a:xfrm>
+          <a:prstGeom prst="rect">
+            <a:avLst/>
+          </a:prstGeom>
+          <a:noFill/>
+          <a:ln/>
+        </p:spPr>
+        <p:txBody>
+          <a:bodyPr wrap="square" lIns="0" tIns="0" rIns="0" bIns="0" rtlCol="0" anchor="t"/>
+          <a:lstStyle/>
+          <a:p>
+            <a:pPr indent="0" marL="0">
+              <a:buNone/>
+            </a:pPr>
+            <a:r>
+              <a:rPr lang="en-US" sz="1200" b="1" dirty="0">
+                <a:solidFill>
+                  <a:srgbClr val="BCE2E7"/>
+                </a:solidFill>
+                <a:latin typeface="Arial" pitchFamily="34" charset="0"/>
+                <a:ea typeface="Arial" pitchFamily="34" charset="-122"/>
+                <a:cs typeface="Arial" pitchFamily="34" charset="-120"/>
+              </a:rPr>
+              <a:t>PROJECT GUIDE</a:t>
+            </a:r>
+            <a:endParaRPr lang="en-US" sz="1200" dirty="0"/>
+          </a:p>
+        </p:txBody>
+      </p:sp>
+      <p:sp>
+        <p:nvSpPr>
+          <p:cNvPr id="6" name="Text 4"/>
+          <p:cNvSpPr/>
+          <p:nvPr/>
+        </p:nvSpPr>
+        <p:spPr>
+          <a:xfrm>
+            <a:off x="4892040" y="1060704"/>
+            <a:ext cx="3657600" cy="365760"/>
+          </a:xfrm>
+          <a:prstGeom prst="rect">
+            <a:avLst/>
+          </a:prstGeom>
+          <a:noFill/>
+          <a:ln/>
+        </p:spPr>
+        <p:txBody>
+          <a:bodyPr wrap="square" lIns="0" tIns="0" rIns="0" bIns="0" rtlCol="0" anchor="t"/>
+          <a:lstStyle/>
+          <a:p>
+            <a:pPr indent="0" marL="0">
+              <a:buNone/>
+            </a:pPr>
+            <a:r>
+              <a:rPr lang="en-US" sz="2200" b="1" dirty="0">
+                <a:solidFill>
+                  <a:srgbClr val="FFFFFF"/>
+                </a:solidFill>
+                <a:latin typeface="Arial" pitchFamily="34" charset="0"/>
+                <a:ea typeface="Arial" pitchFamily="34" charset="-122"/>
+                <a:cs typeface="Arial" pitchFamily="34" charset="-120"/>
+              </a:rPr>
+              <a:t>Dr S. KALYANI</a:t>
+            </a:r>
+            <a:endParaRPr lang="en-US" sz="2200" dirty="0"/>
+          </a:p>
+        </p:txBody>
+      </p:sp>
+      <p:sp>
+        <p:nvSpPr>
+          <p:cNvPr id="7" name="Text 5"/>
+          <p:cNvSpPr/>
+          <p:nvPr/>
+        </p:nvSpPr>
+        <p:spPr>
+          <a:xfrm>
+            <a:off x="4892040" y="1737360"/>
+            <a:ext cx="3657600" cy="228600"/>
+          </a:xfrm>
+          <a:prstGeom prst="rect">
+            <a:avLst/>
+          </a:prstGeom>
+          <a:noFill/>
+          <a:ln/>
+        </p:spPr>
+        <p:txBody>
+          <a:bodyPr wrap="square" lIns="0" tIns="0" rIns="0" bIns="0" rtlCol="0" anchor="t"/>
+          <a:lstStyle/>
+          <a:p>
+            <a:pPr indent="0" marL="0">
+              <a:buNone/>
+            </a:pPr>
+            <a:r>
+              <a:rPr lang="en-US" sz="1200" b="1" dirty="0">
+                <a:solidFill>
+                  <a:srgbClr val="BCE2E7"/>
+                </a:solidFill>
+                <a:latin typeface="Arial" pitchFamily="34" charset="0"/>
+                <a:ea typeface="Arial" pitchFamily="34" charset="-122"/>
+                <a:cs typeface="Arial" pitchFamily="34" charset="-120"/>
+              </a:rPr>
+              <a:t>STUDENTS</a:t>
+            </a:r>
+            <a:endParaRPr lang="en-US" sz="1200" dirty="0"/>
+          </a:p>
+        </p:txBody>
+      </p:sp>
+      <p:sp>
+        <p:nvSpPr>
+          <p:cNvPr id="8" name="Text 6"/>
+          <p:cNvSpPr/>
+          <p:nvPr/>
+        </p:nvSpPr>
+        <p:spPr>
+          <a:xfrm>
+            <a:off x="4892040" y="2148840"/>
+            <a:ext cx="3703320" cy="292608"/>
+          </a:xfrm>
+          <a:prstGeom prst="rect">
+            <a:avLst/>
+          </a:prstGeom>
+          <a:noFill/>
+          <a:ln/>
+        </p:spPr>
+        <p:txBody>
+          <a:bodyPr wrap="square" lIns="0" tIns="0" rIns="0" bIns="0" rtlCol="0" anchor="t"/>
+          <a:lstStyle/>
+          <a:p>
+            <a:pPr indent="0" marL="0">
+              <a:buNone/>
+            </a:pPr>
+            <a:r>
+              <a:rPr lang="en-US" sz="1600" dirty="0">
+                <a:solidFill>
+                  <a:srgbClr val="FFFFFF"/>
+                </a:solidFill>
+                <a:latin typeface="Arial" pitchFamily="34" charset="0"/>
+                <a:ea typeface="Arial" pitchFamily="34" charset="-122"/>
+                <a:cs typeface="Arial" pitchFamily="34" charset="-120"/>
+              </a:rPr>
+              <a:t>24BCA7401 - SHAURYA SINGH</a:t>
+            </a:r>
+            <a:endParaRPr lang="en-US" sz="1600" dirty="0"/>
+          </a:p>
+        </p:txBody>
+      </p:sp>
+      <p:sp>
+        <p:nvSpPr>
+          <p:cNvPr id="9" name="Text 7"/>
+          <p:cNvSpPr/>
+          <p:nvPr/>
+        </p:nvSpPr>
+        <p:spPr>
+          <a:xfrm>
+            <a:off x="4892040" y="2542032"/>
+            <a:ext cx="3703320" cy="292608"/>
+          </a:xfrm>
+          <a:prstGeom prst="rect">
+            <a:avLst/>
+          </a:prstGeom>
+          <a:noFill/>
+          <a:ln/>
+        </p:spPr>
+        <p:txBody>
+          <a:bodyPr wrap="square" lIns="0" tIns="0" rIns="0" bIns="0" rtlCol="0" anchor="t"/>
+          <a:lstStyle/>
+          <a:p>
+            <a:pPr indent="0" marL="0">
+              <a:buNone/>
+            </a:pPr>
+            <a:r>
+              <a:rPr lang="en-US" sz="1600" dirty="0">
+                <a:solidFill>
+                  <a:srgbClr val="FFFFFF"/>
+                </a:solidFill>
+                <a:latin typeface="Arial" pitchFamily="34" charset="0"/>
+                <a:ea typeface="Arial" pitchFamily="34" charset="-122"/>
+                <a:cs typeface="Arial" pitchFamily="34" charset="-120"/>
+              </a:rPr>
+              <a:t>24BCA7167 - K.H.A.Revanth</a:t>
+            </a:r>
+            <a:endParaRPr lang="en-US" sz="1600" dirty="0"/>
+          </a:p>
+        </p:txBody>
+      </p:sp>
+      <p:sp>
+        <p:nvSpPr>
+          <p:cNvPr id="10" name="Text 8"/>
+          <p:cNvSpPr/>
+          <p:nvPr/>
+        </p:nvSpPr>
+        <p:spPr>
+          <a:xfrm>
+            <a:off x="4892040" y="2935224"/>
+            <a:ext cx="3703320" cy="292608"/>
+          </a:xfrm>
+          <a:prstGeom prst="rect">
+            <a:avLst/>
+          </a:prstGeom>
+          <a:noFill/>
+          <a:ln/>
+        </p:spPr>
+        <p:txBody>
+          <a:bodyPr wrap="square" lIns="0" tIns="0" rIns="0" bIns="0" rtlCol="0" anchor="t"/>
+          <a:lstStyle/>
+          <a:p>
+            <a:pPr indent="0" marL="0">
+              <a:buNone/>
+            </a:pPr>
+            <a:r>
+              <a:rPr lang="en-US" sz="1600" dirty="0">
+                <a:solidFill>
+                  <a:srgbClr val="FFFFFF"/>
+                </a:solidFill>
+                <a:latin typeface="Arial" pitchFamily="34" charset="0"/>
+                <a:ea typeface="Arial" pitchFamily="34" charset="-122"/>
+                <a:cs typeface="Arial" pitchFamily="34" charset="-120"/>
+              </a:rPr>
+              <a:t>24BCA7171 - K Yuva Karthik</a:t>
+            </a:r>
+            <a:endParaRPr lang="en-US" sz="1600" dirty="0"/>
+          </a:p>
+        </p:txBody>
+      </p:sp>
+      <p:sp>
+        <p:nvSpPr>
+          <p:cNvPr id="11" name="Text 9"/>
+          <p:cNvSpPr/>
+          <p:nvPr/>
+        </p:nvSpPr>
+        <p:spPr>
+          <a:xfrm>
+            <a:off x="4892040" y="3328416"/>
+            <a:ext cx="3703320" cy="292608"/>
+          </a:xfrm>
+          <a:prstGeom prst="rect">
+            <a:avLst/>
+          </a:prstGeom>
+          <a:noFill/>
+          <a:ln/>
+        </p:spPr>
+        <p:txBody>
+          <a:bodyPr wrap="square" lIns="0" tIns="0" rIns="0" bIns="0" rtlCol="0" anchor="t"/>
+          <a:lstStyle/>
+          <a:p>
+            <a:pPr indent="0" marL="0">
+              <a:buNone/>
+            </a:pPr>
+            <a:r>
+              <a:rPr lang="en-US" sz="1600" dirty="0">
+                <a:solidFill>
+                  <a:srgbClr val="FFFFFF"/>
+                </a:solidFill>
+                <a:latin typeface="Arial" pitchFamily="34" charset="0"/>
+                <a:ea typeface="Arial" pitchFamily="34" charset="-122"/>
+                <a:cs typeface="Arial" pitchFamily="34" charset="-120"/>
+              </a:rPr>
+              <a:t>24BCE7026 - Likith R</a:t>
+            </a:r>
+            <a:endParaRPr lang="en-US" sz="1600" dirty="0"/>
+          </a:p>
+        </p:txBody>
+      </p:sp>
+      <p:sp>
+        <p:nvSpPr>
+          <p:cNvPr id="12" name="Text 10"/>
+          <p:cNvSpPr/>
+          <p:nvPr/>
+        </p:nvSpPr>
+        <p:spPr>
+          <a:xfrm>
+            <a:off x="4892040" y="3721608"/>
+            <a:ext cx="3703320" cy="292608"/>
+          </a:xfrm>
+          <a:prstGeom prst="rect">
+            <a:avLst/>
+          </a:prstGeom>
+          <a:noFill/>
+          <a:ln/>
+        </p:spPr>
+        <p:txBody>
+          <a:bodyPr wrap="square" lIns="0" tIns="0" rIns="0" bIns="0" rtlCol="0" anchor="t"/>
+          <a:lstStyle/>
+          <a:p>
+            <a:pPr indent="0" marL="0">
+              <a:buNone/>
+            </a:pPr>
+            <a:r>
+              <a:rPr lang="en-US" sz="1600" dirty="0">
+                <a:solidFill>
+                  <a:srgbClr val="FFFFFF"/>
+                </a:solidFill>
+                <a:latin typeface="Arial" pitchFamily="34" charset="0"/>
+                <a:ea typeface="Arial" pitchFamily="34" charset="-122"/>
+                <a:cs typeface="Arial" pitchFamily="34" charset="-120"/>
+              </a:rPr>
+              <a:t>24BCA7040 - Hima Tejaswi</a:t>
+            </a:r>
+            <a:endParaRPr lang="en-US" sz="1600" dirty="0"/>
+          </a:p>
+        </p:txBody>
+      </p:sp>
+      <p:sp>
+        <p:nvSpPr>
+          <p:cNvPr id="13" name="Text 11"/>
           <p:cNvSpPr/>
           <p:nvPr/>
         </p:nvSpPr>
@@ -2077,7 +2407,7 @@
               <a:buNone/>
             </a:pPr>
             <a:r>
-              <a:rPr lang="en-US" sz="1300" dirty="0">
+              <a:rPr lang="en-US" sz="1400" b="1" dirty="0">
                 <a:solidFill>
                   <a:srgbClr val="BCE2E7"/>
                 </a:solidFill>
@@ -2085,15 +2415,15 @@
                 <a:ea typeface="Arial" pitchFamily="34" charset="-122"/>
                 <a:cs typeface="Arial" pitchFamily="34" charset="-120"/>
               </a:rPr>
-              <a:t>prototype/rl-academic-complete  |  code baseline 92a1296</a:t>
-            </a:r>
-            <a:endParaRPr lang="en-US" sz="1300" dirty="0"/>
-          </a:p>
-        </p:txBody>
-      </p:sp>
-      <p:sp>
-        <p:nvSpPr>
-          <p:cNvPr id="6" name="Text 4"/>
+              <a:t>Final project branch: prototype/rl-academic-complete</a:t>
+            </a:r>
+            <a:endParaRPr lang="en-US" sz="1400" dirty="0"/>
+          </a:p>
+        </p:txBody>
+      </p:sp>
+      <p:sp>
+        <p:nvSpPr>
+          <p:cNvPr id="14" name="Text 12"/>
           <p:cNvSpPr/>
           <p:nvPr/>
         </p:nvSpPr>
@@ -3594,7 +3924,7 @@
         </p:nvSpPr>
         <p:spPr>
           <a:xfrm>
-            <a:off x="457200" y="2596896"/>
+            <a:off x="457200" y="2514600"/>
             <a:ext cx="8229600" cy="365760"/>
           </a:xfrm>
           <a:prstGeom prst="rect">
@@ -3633,7 +3963,7 @@
         </p:nvSpPr>
         <p:spPr>
           <a:xfrm>
-            <a:off x="457200" y="3154680"/>
+            <a:off x="457200" y="3063240"/>
             <a:ext cx="3840480" cy="320040"/>
           </a:xfrm>
           <a:prstGeom prst="rect">
@@ -3672,8 +4002,8 @@
         </p:nvSpPr>
         <p:spPr>
           <a:xfrm>
-            <a:off x="457200" y="3621024"/>
-            <a:ext cx="3749040" cy="640080"/>
+            <a:off x="457200" y="3511296"/>
+            <a:ext cx="3749040" cy="594360"/>
           </a:xfrm>
           <a:prstGeom prst="rect">
             <a:avLst/>
@@ -3728,7 +4058,7 @@
         </p:nvSpPr>
         <p:spPr>
           <a:xfrm>
-            <a:off x="4572000" y="3154680"/>
+            <a:off x="4572000" y="3063240"/>
             <a:ext cx="4114800" cy="320040"/>
           </a:xfrm>
           <a:prstGeom prst="rect">
@@ -3767,8 +4097,8 @@
         </p:nvSpPr>
         <p:spPr>
           <a:xfrm>
-            <a:off x="4572000" y="3621024"/>
-            <a:ext cx="4114800" cy="640080"/>
+            <a:off x="4572000" y="3511296"/>
+            <a:ext cx="4114800" cy="594360"/>
           </a:xfrm>
           <a:prstGeom prst="rect">
             <a:avLst/>
@@ -4368,7 +4698,7 @@
         </p:nvSpPr>
         <p:spPr>
           <a:xfrm>
-            <a:off x="457200" y="3931920"/>
+            <a:off x="457200" y="3785616"/>
             <a:ext cx="8229600" cy="274320"/>
           </a:xfrm>
           <a:prstGeom prst="rect">
@@ -4913,7 +5243,7 @@
         </p:nvGraphicFramePr>
         <p:xfrm>
           <a:off x="457200" y="2487168"/>
-          <a:ext cx="5349240" cy="1783080"/>
+          <a:ext cx="5349240" cy="1554480"/>
         </p:xfrm>
         <a:graphic xmlns:a="http://schemas.openxmlformats.org/drawingml/2006/main">
           <a:graphicData uri="http://schemas.openxmlformats.org/drawingml/2006/chart">
@@ -4929,24 +5259,24 @@
         </p:nvSpPr>
         <p:spPr>
           <a:xfrm>
-            <a:off x="6080760" y="2331720"/>
-            <a:ext cx="2606040" cy="777240"/>
-          </a:xfrm>
-          <a:prstGeom prst="rect">
-            <a:avLst/>
-          </a:prstGeom>
-          <a:noFill/>
-          <a:ln/>
-        </p:spPr>
-        <p:txBody>
-          <a:bodyPr wrap="square" lIns="0" tIns="0" rIns="0" bIns="0" rtlCol="0" anchor="t"/>
-          <a:lstStyle/>
-          <a:p>
-            <a:pPr indent="0" marL="0">
-              <a:buNone/>
-            </a:pPr>
-            <a:r>
-              <a:rPr lang="en-US" sz="1300" b="1" dirty="0">
+            <a:off x="6080760" y="2286000"/>
+            <a:ext cx="2606040" cy="749808"/>
+          </a:xfrm>
+          <a:prstGeom prst="rect">
+            <a:avLst/>
+          </a:prstGeom>
+          <a:noFill/>
+          <a:ln/>
+        </p:spPr>
+        <p:txBody>
+          <a:bodyPr wrap="square" lIns="0" tIns="0" rIns="0" bIns="0" rtlCol="0" anchor="t"/>
+          <a:lstStyle/>
+          <a:p>
+            <a:pPr indent="0" marL="0">
+              <a:buNone/>
+            </a:pPr>
+            <a:r>
+              <a:rPr lang="en-US" sz="1400" b="1" dirty="0">
                 <a:solidFill>
                   <a:srgbClr val="172D30"/>
                 </a:solidFill>
@@ -4954,7 +5284,80 @@
                 <a:ea typeface="Arial" pitchFamily="34" charset="-122"/>
                 <a:cs typeface="Arial" pitchFamily="34" charset="-120"/>
               </a:rPr>
-              <a:t>High-value-burst workload</a:t>
+              <a:t>All campaigns (pooled)</a:t>
+            </a:r>
+            <a:endParaRPr lang="en-US" sz="1400" dirty="0"/>
+          </a:p>
+          <a:p>
+            <a:pPr indent="0" marL="0">
+              <a:buNone/>
+            </a:pPr>
+            <a:r>
+              <a:rPr lang="en-US" sz="1400" b="1" dirty="0">
+                <a:solidFill>
+                  <a:srgbClr val="172D30"/>
+                </a:solidFill>
+                <a:latin typeface="Arial" pitchFamily="34" charset="0"/>
+                <a:ea typeface="Arial" pitchFamily="34" charset="-122"/>
+                <a:cs typeface="Arial" pitchFamily="34" charset="-120"/>
+              </a:rPr>
+              <a:t>1,077 / 1,152 = 93.490%</a:t>
+            </a:r>
+            <a:endParaRPr lang="en-US" sz="1400" dirty="0"/>
+          </a:p>
+          <a:p>
+            <a:pPr indent="0" marL="0">
+              <a:buNone/>
+            </a:pPr>
+            <a:r>
+              <a:rPr lang="en-US" sz="1400" b="1" dirty="0">
+                <a:solidFill>
+                  <a:srgbClr val="172D30"/>
+                </a:solidFill>
+                <a:latin typeface="Arial" pitchFamily="34" charset="0"/>
+                <a:ea typeface="Arial" pitchFamily="34" charset="-122"/>
+                <a:cs typeface="Arial" pitchFamily="34" charset="-120"/>
+              </a:rPr>
+              <a:t>reached their target.</a:t>
+            </a:r>
+            <a:endParaRPr lang="en-US" sz="1400" dirty="0"/>
+          </a:p>
+        </p:txBody>
+      </p:sp>
+      <p:sp>
+        <p:nvSpPr>
+          <p:cNvPr id="16" name="Text 13"/>
+          <p:cNvSpPr/>
+          <p:nvPr/>
+        </p:nvSpPr>
+        <p:spPr>
+          <a:xfrm>
+            <a:off x="6080760" y="3154680"/>
+            <a:ext cx="2606040" cy="502920"/>
+          </a:xfrm>
+          <a:prstGeom prst="rect">
+            <a:avLst/>
+          </a:prstGeom>
+          <a:noFill/>
+          <a:ln/>
+        </p:spPr>
+        <p:txBody>
+          <a:bodyPr wrap="square" lIns="0" tIns="0" rIns="0" bIns="0" rtlCol="0" anchor="t"/>
+          <a:lstStyle/>
+          <a:p>
+            <a:pPr indent="0" marL="0">
+              <a:buNone/>
+            </a:pPr>
+            <a:r>
+              <a:rPr lang="en-US" sz="1300" dirty="0">
+                <a:solidFill>
+                  <a:srgbClr val="465E62"/>
+                </a:solidFill>
+                <a:latin typeface="Arial" pitchFamily="34" charset="0"/>
+                <a:ea typeface="Arial" pitchFamily="34" charset="-122"/>
+                <a:cs typeface="Arial" pitchFamily="34" charset="-120"/>
+              </a:rPr>
+              <a:t>Not detector accuracy</a:t>
             </a:r>
             <a:endParaRPr lang="en-US" sz="1300" dirty="0"/>
           </a:p>
@@ -4963,47 +5366,30 @@
               <a:buNone/>
             </a:pPr>
             <a:r>
-              <a:rPr lang="en-US" sz="1300" b="1" dirty="0">
-                <a:solidFill>
-                  <a:srgbClr val="172D30"/>
-                </a:solidFill>
-                <a:latin typeface="Arial" pitchFamily="34" charset="0"/>
-                <a:ea typeface="Arial" pitchFamily="34" charset="-122"/>
-                <a:cs typeface="Arial" pitchFamily="34" charset="-120"/>
-              </a:rPr>
-              <a:t>72 campaigns per arm / detector</a:t>
+              <a:rPr lang="en-US" sz="1300" dirty="0">
+                <a:solidFill>
+                  <a:srgbClr val="465E62"/>
+                </a:solidFill>
+                <a:latin typeface="Arial" pitchFamily="34" charset="0"/>
+                <a:ea typeface="Arial" pitchFamily="34" charset="-122"/>
+                <a:cs typeface="Arial" pitchFamily="34" charset="-120"/>
+              </a:rPr>
+              <a:t>or proof of RL superiority.</a:t>
             </a:r>
             <a:endParaRPr lang="en-US" sz="1300" dirty="0"/>
           </a:p>
-          <a:p>
-            <a:pPr indent="0" marL="0">
-              <a:buNone/>
-            </a:pPr>
-            <a:r>
-              <a:rPr lang="en-US" sz="1300" b="1" dirty="0">
-                <a:solidFill>
-                  <a:srgbClr val="172D30"/>
-                </a:solidFill>
-                <a:latin typeface="Arial" pitchFamily="34" charset="0"/>
-                <a:ea typeface="Arial" pitchFamily="34" charset="-122"/>
-                <a:cs typeface="Arial" pitchFamily="34" charset="-120"/>
-              </a:rPr>
-              <a:t>3 seed-level replications</a:t>
-            </a:r>
-            <a:endParaRPr lang="en-US" sz="1300" dirty="0"/>
-          </a:p>
-        </p:txBody>
-      </p:sp>
-      <p:sp>
-        <p:nvSpPr>
-          <p:cNvPr id="16" name="Text 13"/>
-          <p:cNvSpPr/>
-          <p:nvPr/>
-        </p:nvSpPr>
-        <p:spPr>
-          <a:xfrm>
-            <a:off x="6080760" y="3090672"/>
-            <a:ext cx="2606040" cy="228600"/>
+        </p:txBody>
+      </p:sp>
+      <p:sp>
+        <p:nvSpPr>
+          <p:cNvPr id="17" name="Text 14"/>
+          <p:cNvSpPr/>
+          <p:nvPr/>
+        </p:nvSpPr>
+        <p:spPr>
+          <a:xfrm>
+            <a:off x="6080760" y="3685032"/>
+            <a:ext cx="2606040" cy="457200"/>
           </a:xfrm>
           <a:prstGeom prst="rect">
             <a:avLst/>
@@ -5027,38 +5413,16 @@
                 <a:ea typeface="Arial" pitchFamily="34" charset="-122"/>
                 <a:cs typeface="Arial" pitchFamily="34" charset="-120"/>
               </a:rPr>
-              <a:t>Seed SDs: speaker notes.</a:t>
+              <a:t>Chart: high-value burst only.</a:t>
             </a:r>
             <a:endParaRPr lang="en-US" sz="1100" dirty="0"/>
           </a:p>
-        </p:txBody>
-      </p:sp>
-      <p:sp>
-        <p:nvSpPr>
-          <p:cNvPr id="17" name="Text 14"/>
-          <p:cNvSpPr/>
-          <p:nvPr/>
-        </p:nvSpPr>
-        <p:spPr>
-          <a:xfrm>
-            <a:off x="6080760" y="3383280"/>
-            <a:ext cx="2606040" cy="685800"/>
-          </a:xfrm>
-          <a:prstGeom prst="rect">
-            <a:avLst/>
-          </a:prstGeom>
-          <a:noFill/>
-          <a:ln/>
-        </p:spPr>
-        <p:txBody>
-          <a:bodyPr wrap="square" lIns="0" tIns="0" rIns="0" bIns="0" rtlCol="0" anchor="t"/>
-          <a:lstStyle/>
-          <a:p>
-            <a:pPr indent="0" marL="0">
-              <a:buNone/>
-            </a:pPr>
-            <a:r>
-              <a:rPr lang="en-US" sz="1400" dirty="0">
+          <a:p>
+            <a:pPr indent="0" marL="0">
+              <a:buNone/>
+            </a:pPr>
+            <a:r>
+              <a:rPr lang="en-US" sz="1100" dirty="0">
                 <a:solidFill>
                   <a:srgbClr val="465E62"/>
                 </a:solidFill>
@@ -5066,16 +5430,16 @@
                 <a:ea typeface="Arial" pitchFamily="34" charset="-122"/>
                 <a:cs typeface="Arial" pitchFamily="34" charset="-120"/>
               </a:rPr>
-              <a:t>Historical, confounded comparisons.</a:t>
-            </a:r>
-            <a:endParaRPr lang="en-US" sz="1400" dirty="0"/>
-          </a:p>
-          <a:p>
-            <a:pPr indent="0" marL="0">
-              <a:buNone/>
-            </a:pPr>
-            <a:r>
-              <a:rPr lang="en-US" sz="1400" dirty="0">
+              <a:t>72 per arm / detector; 3 seeds.</a:t>
+            </a:r>
+            <a:endParaRPr lang="en-US" sz="1100" dirty="0"/>
+          </a:p>
+          <a:p>
+            <a:pPr indent="0" marL="0">
+              <a:buNone/>
+            </a:pPr>
+            <a:r>
+              <a:rPr lang="en-US" sz="1100" dirty="0">
                 <a:solidFill>
                   <a:srgbClr val="465E62"/>
                 </a:solidFill>
@@ -5083,26 +5447,9 @@
                 <a:ea typeface="Arial" pitchFamily="34" charset="-122"/>
                 <a:cs typeface="Arial" pitchFamily="34" charset="-120"/>
               </a:rPr>
-              <a:t>Not detector accuracy or proof</a:t>
-            </a:r>
-            <a:endParaRPr lang="en-US" sz="1400" dirty="0"/>
-          </a:p>
-          <a:p>
-            <a:pPr indent="0" marL="0">
-              <a:buNone/>
-            </a:pPr>
-            <a:r>
-              <a:rPr lang="en-US" sz="1400" dirty="0">
-                <a:solidFill>
-                  <a:srgbClr val="465E62"/>
-                </a:solidFill>
-                <a:latin typeface="Arial" pitchFamily="34" charset="0"/>
-                <a:ea typeface="Arial" pitchFamily="34" charset="-122"/>
-                <a:cs typeface="Arial" pitchFamily="34" charset="-120"/>
-              </a:rPr>
-              <a:t>of RL superiority.</a:t>
-            </a:r>
-            <a:endParaRPr lang="en-US" sz="1400" dirty="0"/>
+              <a:t>Seed SDs in notes; confounded.</a:t>
+            </a:r>
+            <a:endParaRPr lang="en-US" sz="1100" dirty="0"/>
           </a:p>
         </p:txBody>
       </p:sp>
@@ -5171,7 +5518,7 @@
                 <a:ea typeface="Arial" pitchFamily="34" charset="-122"/>
                 <a:cs typeface="Arial" pitchFamily="34" charset="-120"/>
               </a:rPr>
-              <a:t>A bounded engineering contribution</a:t>
+              <a:t>Terminal results: what do they mean?</a:t>
             </a:r>
             <a:endParaRPr lang="en-US" sz="3400" dirty="0"/>
           </a:p>
@@ -5333,7 +5680,7 @@
                   </a:extLst>
                 </a:hlinkClick>
               </a:rPr>
-              <a:t>source-grounded literature matrix (review branch)</a:t>
+              <a:t>saved short-run stdout and interpretation</a:t>
             </a:r>
             <a:endParaRPr lang="en-US" sz="1000" dirty="0"/>
           </a:p>
@@ -5347,63 +5694,24 @@
         </p:nvSpPr>
         <p:spPr>
           <a:xfrm>
-            <a:off x="457200" y="1371600"/>
-            <a:ext cx="3840480" cy="365760"/>
-          </a:xfrm>
-          <a:prstGeom prst="rect">
-            <a:avLst/>
-          </a:prstGeom>
-          <a:noFill/>
-          <a:ln/>
-        </p:spPr>
-        <p:txBody>
-          <a:bodyPr wrap="square" lIns="0" tIns="0" rIns="0" bIns="0" rtlCol="0" anchor="t"/>
-          <a:lstStyle/>
-          <a:p>
-            <a:pPr indent="0" marL="0">
-              <a:buNone/>
-            </a:pPr>
-            <a:r>
-              <a:rPr lang="en-US" sz="2300" b="1" dirty="0">
-                <a:solidFill>
-                  <a:srgbClr val="172D30"/>
-                </a:solidFill>
-                <a:latin typeface="Arial" pitchFamily="34" charset="0"/>
-                <a:ea typeface="Arial" pitchFamily="34" charset="-122"/>
-                <a:cs typeface="Arial" pitchFamily="34" charset="-120"/>
-              </a:rPr>
-              <a:t>Existing methods</a:t>
-            </a:r>
-            <a:endParaRPr lang="en-US" sz="2300" dirty="0"/>
-          </a:p>
-        </p:txBody>
-      </p:sp>
-      <p:sp>
-        <p:nvSpPr>
-          <p:cNvPr id="8" name="Text 6"/>
-          <p:cNvSpPr/>
-          <p:nvPr/>
-        </p:nvSpPr>
-        <p:spPr>
-          <a:xfrm>
-            <a:off x="457200" y="2194560"/>
-            <a:ext cx="3749040" cy="1508760"/>
-          </a:xfrm>
-          <a:prstGeom prst="rect">
-            <a:avLst/>
-          </a:prstGeom>
-          <a:noFill/>
-          <a:ln/>
-        </p:spPr>
-        <p:txBody>
-          <a:bodyPr wrap="square" lIns="0" tIns="0" rIns="0" bIns="0" rtlCol="0" anchor="t"/>
-          <a:lstStyle/>
-          <a:p>
-            <a:pPr indent="0" marL="0">
-              <a:buNone/>
-            </a:pPr>
-            <a:r>
-              <a:rPr lang="en-US" sz="1900" dirty="0">
+            <a:off x="457200" y="1325880"/>
+            <a:ext cx="8229600" cy="320040"/>
+          </a:xfrm>
+          <a:prstGeom prst="rect">
+            <a:avLst/>
+          </a:prstGeom>
+          <a:noFill/>
+          <a:ln/>
+        </p:spPr>
+        <p:txBody>
+          <a:bodyPr wrap="square" lIns="0" tIns="0" rIns="0" bIns="0" rtlCol="0" anchor="t"/>
+          <a:lstStyle/>
+          <a:p>
+            <a:pPr indent="0" marL="0">
+              <a:buNone/>
+            </a:pPr>
+            <a:r>
+              <a:rPr lang="en-US" sz="1500" dirty="0">
                 <a:solidFill>
                   <a:srgbClr val="202B2D"/>
                 </a:solidFill>
@@ -5411,16 +5719,177 @@
                 <a:ea typeface="Arial" pitchFamily="34" charset="-122"/>
                 <a:cs typeface="Arial" pitchFamily="34" charset="-120"/>
               </a:rPr>
-              <a:t>Fraud classification</a:t>
-            </a:r>
-            <a:endParaRPr lang="en-US" sz="1900" dirty="0"/>
-          </a:p>
-          <a:p>
-            <a:pPr indent="0" marL="0">
-              <a:buNone/>
-            </a:pPr>
-            <a:r>
-              <a:rPr lang="en-US" sz="1900" dirty="0">
+              <a:t>Recorded short demo: 16 campaigns, 4 training episodes; 1 campaign per cell.</a:t>
+            </a:r>
+            <a:endParaRPr lang="en-US" sz="1500" dirty="0"/>
+          </a:p>
+        </p:txBody>
+      </p:sp>
+      <p:sp>
+        <p:nvSpPr>
+          <p:cNvPr id="8" name="Shape 6"/>
+          <p:cNvSpPr/>
+          <p:nvPr/>
+        </p:nvSpPr>
+        <p:spPr>
+          <a:xfrm>
+            <a:off x="457200" y="1828800"/>
+            <a:ext cx="8229600" cy="868680"/>
+          </a:xfrm>
+          <a:prstGeom prst="rect">
+            <a:avLst/>
+          </a:prstGeom>
+          <a:solidFill>
+            <a:srgbClr val="172D30"/>
+          </a:solidFill>
+          <a:ln w="12700">
+            <a:solidFill>
+              <a:srgbClr val="172D30">
+                <a:alpha val="0"/>
+              </a:srgbClr>
+            </a:solidFill>
+            <a:prstDash val="solid"/>
+          </a:ln>
+        </p:spPr>
+      </p:sp>
+      <p:sp>
+        <p:nvSpPr>
+          <p:cNvPr id="9" name="Text 7"/>
+          <p:cNvSpPr/>
+          <p:nvPr/>
+        </p:nvSpPr>
+        <p:spPr>
+          <a:xfrm>
+            <a:off x="612648" y="1956816"/>
+            <a:ext cx="7909560" cy="640080"/>
+          </a:xfrm>
+          <a:prstGeom prst="rect">
+            <a:avLst/>
+          </a:prstGeom>
+          <a:noFill/>
+          <a:ln/>
+        </p:spPr>
+        <p:txBody>
+          <a:bodyPr wrap="square" lIns="0" tIns="0" rIns="0" bIns="0" rtlCol="0" anchor="t"/>
+          <a:lstStyle/>
+          <a:p>
+            <a:pPr indent="0" marL="0">
+              <a:buNone/>
+            </a:pPr>
+            <a:r>
+              <a:rPr lang="en-US" sz="1200" dirty="0">
+                <a:solidFill>
+                  <a:srgbClr val="FFFFFF"/>
+                </a:solidFill>
+                <a:latin typeface="Courier New" pitchFamily="34" charset="0"/>
+                <a:ea typeface="Courier New" pitchFamily="34" charset="-122"/>
+                <a:cs typeface="Courier New" pitchFamily="34" charset="-120"/>
+              </a:rPr>
+              <a:t>xgboost known static success=1.000 exposure=46791.56</a:t>
+            </a:r>
+            <a:endParaRPr lang="en-US" sz="1200" dirty="0"/>
+          </a:p>
+          <a:p>
+            <a:pPr indent="0" marL="0">
+              <a:buNone/>
+            </a:pPr>
+            <a:r>
+              <a:rPr lang="en-US" sz="1200" dirty="0">
+                <a:solidFill>
+                  <a:srgbClr val="FFFFFF"/>
+                </a:solidFill>
+                <a:latin typeface="Courier New" pitchFamily="34" charset="0"/>
+                <a:ea typeface="Courier New" pitchFamily="34" charset="-122"/>
+                <a:cs typeface="Courier New" pitchFamily="34" charset="-120"/>
+              </a:rPr>
+              <a:t>xgboost known rl success=1.000 exposure=29789.42</a:t>
+            </a:r>
+            <a:endParaRPr lang="en-US" sz="1200" dirty="0"/>
+          </a:p>
+          <a:p>
+            <a:pPr indent="0" marL="0">
+              <a:buNone/>
+            </a:pPr>
+            <a:r>
+              <a:rPr lang="en-US" sz="1200" dirty="0">
+                <a:solidFill>
+                  <a:srgbClr val="FFFFFF"/>
+                </a:solidFill>
+                <a:latin typeface="Courier New" pitchFamily="34" charset="0"/>
+                <a:ea typeface="Courier New" pitchFamily="34" charset="-122"/>
+                <a:cs typeface="Courier New" pitchFamily="34" charset="-120"/>
+              </a:rPr>
+              <a:t>random_forest known rl success=1.000 exposure=29789.42</a:t>
+            </a:r>
+            <a:endParaRPr lang="en-US" sz="1200" dirty="0"/>
+          </a:p>
+        </p:txBody>
+      </p:sp>
+      <p:sp>
+        <p:nvSpPr>
+          <p:cNvPr id="10" name="Text 8"/>
+          <p:cNvSpPr/>
+          <p:nvPr/>
+        </p:nvSpPr>
+        <p:spPr>
+          <a:xfrm>
+            <a:off x="457200" y="2880360"/>
+            <a:ext cx="1463040" cy="274320"/>
+          </a:xfrm>
+          <a:prstGeom prst="rect">
+            <a:avLst/>
+          </a:prstGeom>
+          <a:noFill/>
+          <a:ln/>
+        </p:spPr>
+        <p:txBody>
+          <a:bodyPr wrap="square" lIns="0" tIns="0" rIns="0" bIns="0" rtlCol="0" anchor="t"/>
+          <a:lstStyle/>
+          <a:p>
+            <a:pPr indent="0" marL="0">
+              <a:buNone/>
+            </a:pPr>
+            <a:r>
+              <a:rPr lang="en-US" sz="1300" b="1" dirty="0">
+                <a:solidFill>
+                  <a:srgbClr val="01696F"/>
+                </a:solidFill>
+                <a:latin typeface="Arial" pitchFamily="34" charset="0"/>
+                <a:ea typeface="Arial" pitchFamily="34" charset="-122"/>
+                <a:cs typeface="Arial" pitchFamily="34" charset="-120"/>
+              </a:rPr>
+              <a:t>success=1.000</a:t>
+            </a:r>
+            <a:endParaRPr lang="en-US" sz="1300" dirty="0"/>
+          </a:p>
+        </p:txBody>
+      </p:sp>
+      <p:sp>
+        <p:nvSpPr>
+          <p:cNvPr id="11" name="Text 9"/>
+          <p:cNvSpPr/>
+          <p:nvPr/>
+        </p:nvSpPr>
+        <p:spPr>
+          <a:xfrm>
+            <a:off x="1965960" y="2880360"/>
+            <a:ext cx="6720840" cy="274320"/>
+          </a:xfrm>
+          <a:prstGeom prst="rect">
+            <a:avLst/>
+          </a:prstGeom>
+          <a:noFill/>
+          <a:ln/>
+        </p:spPr>
+        <p:txBody>
+          <a:bodyPr wrap="square" lIns="0" tIns="0" rIns="0" bIns="0" rtlCol="0" anchor="t"/>
+          <a:lstStyle/>
+          <a:p>
+            <a:pPr indent="0" marL="0">
+              <a:buNone/>
+            </a:pPr>
+            <a:r>
+              <a:rPr lang="en-US" sz="1400" dirty="0">
                 <a:solidFill>
                   <a:srgbClr val="202B2D"/>
                 </a:solidFill>
@@ -5428,16 +5897,77 @@
                 <a:ea typeface="Arial" pitchFamily="34" charset="-122"/>
                 <a:cs typeface="Arial" pitchFamily="34" charset="-120"/>
               </a:rPr>
-              <a:t>Sequential modelling</a:t>
-            </a:r>
-            <a:endParaRPr lang="en-US" sz="1900" dirty="0"/>
-          </a:p>
-          <a:p>
-            <a:pPr indent="0" marL="0">
-              <a:buNone/>
-            </a:pPr>
-            <a:r>
-              <a:rPr lang="en-US" sz="1900" dirty="0">
+              <a:t>That configuration reached its target in 1 of 1 campaigns.</a:t>
+            </a:r>
+            <a:endParaRPr lang="en-US" sz="1400" dirty="0"/>
+          </a:p>
+        </p:txBody>
+      </p:sp>
+      <p:sp>
+        <p:nvSpPr>
+          <p:cNvPr id="12" name="Text 10"/>
+          <p:cNvSpPr/>
+          <p:nvPr/>
+        </p:nvSpPr>
+        <p:spPr>
+          <a:xfrm>
+            <a:off x="457200" y="3218688"/>
+            <a:ext cx="1463040" cy="274320"/>
+          </a:xfrm>
+          <a:prstGeom prst="rect">
+            <a:avLst/>
+          </a:prstGeom>
+          <a:noFill/>
+          <a:ln/>
+        </p:spPr>
+        <p:txBody>
+          <a:bodyPr wrap="square" lIns="0" tIns="0" rIns="0" bIns="0" rtlCol="0" anchor="t"/>
+          <a:lstStyle/>
+          <a:p>
+            <a:pPr indent="0" marL="0">
+              <a:buNone/>
+            </a:pPr>
+            <a:r>
+              <a:rPr lang="en-US" sz="1300" b="1" dirty="0">
+                <a:solidFill>
+                  <a:srgbClr val="01696F"/>
+                </a:solidFill>
+                <a:latin typeface="Arial" pitchFamily="34" charset="0"/>
+                <a:ea typeface="Arial" pitchFamily="34" charset="-122"/>
+                <a:cs typeface="Arial" pitchFamily="34" charset="-120"/>
+              </a:rPr>
+              <a:t>exposure</a:t>
+            </a:r>
+            <a:endParaRPr lang="en-US" sz="1300" dirty="0"/>
+          </a:p>
+        </p:txBody>
+      </p:sp>
+      <p:sp>
+        <p:nvSpPr>
+          <p:cNvPr id="13" name="Text 11"/>
+          <p:cNvSpPr/>
+          <p:nvPr/>
+        </p:nvSpPr>
+        <p:spPr>
+          <a:xfrm>
+            <a:off x="1965960" y="3218688"/>
+            <a:ext cx="6720840" cy="274320"/>
+          </a:xfrm>
+          <a:prstGeom prst="rect">
+            <a:avLst/>
+          </a:prstGeom>
+          <a:noFill/>
+          <a:ln/>
+        </p:spPr>
+        <p:txBody>
+          <a:bodyPr wrap="square" lIns="0" tIns="0" rIns="0" bIns="0" rtlCol="0" anchor="t"/>
+          <a:lstStyle/>
+          <a:p>
+            <a:pPr indent="0" marL="0">
+              <a:buNone/>
+            </a:pPr>
+            <a:r>
+              <a:rPr lang="en-US" sz="1400" dirty="0">
                 <a:solidFill>
                   <a:srgbClr val="202B2D"/>
                 </a:solidFill>
@@ -5445,16 +5975,77 @@
                 <a:ea typeface="Arial" pitchFamily="34" charset="-122"/>
                 <a:cs typeface="Arial" pitchFamily="34" charset="-120"/>
               </a:rPr>
-              <a:t>Adversarial evasion</a:t>
-            </a:r>
-            <a:endParaRPr lang="en-US" sz="1900" dirty="0"/>
-          </a:p>
-          <a:p>
-            <a:pPr indent="0" marL="0">
-              <a:buNone/>
-            </a:pPr>
-            <a:r>
-              <a:rPr lang="en-US" sz="1900" dirty="0">
+              <a:t>Gross simulated source debit in INR, not actual victim loss.</a:t>
+            </a:r>
+            <a:endParaRPr lang="en-US" sz="1400" dirty="0"/>
+          </a:p>
+        </p:txBody>
+      </p:sp>
+      <p:sp>
+        <p:nvSpPr>
+          <p:cNvPr id="14" name="Text 12"/>
+          <p:cNvSpPr/>
+          <p:nvPr/>
+        </p:nvSpPr>
+        <p:spPr>
+          <a:xfrm>
+            <a:off x="457200" y="3557016"/>
+            <a:ext cx="1463040" cy="274320"/>
+          </a:xfrm>
+          <a:prstGeom prst="rect">
+            <a:avLst/>
+          </a:prstGeom>
+          <a:noFill/>
+          <a:ln/>
+        </p:spPr>
+        <p:txBody>
+          <a:bodyPr wrap="square" lIns="0" tIns="0" rIns="0" bIns="0" rtlCol="0" anchor="t"/>
+          <a:lstStyle/>
+          <a:p>
+            <a:pPr indent="0" marL="0">
+              <a:buNone/>
+            </a:pPr>
+            <a:r>
+              <a:rPr lang="en-US" sz="1300" b="1" dirty="0">
+                <a:solidFill>
+                  <a:srgbClr val="01696F"/>
+                </a:solidFill>
+                <a:latin typeface="Arial" pitchFamily="34" charset="0"/>
+                <a:ea typeface="Arial" pitchFamily="34" charset="-122"/>
+                <a:cs typeface="Arial" pitchFamily="34" charset="-120"/>
+              </a:rPr>
+              <a:t>known</a:t>
+            </a:r>
+            <a:endParaRPr lang="en-US" sz="1300" dirty="0"/>
+          </a:p>
+        </p:txBody>
+      </p:sp>
+      <p:sp>
+        <p:nvSpPr>
+          <p:cNvPr id="15" name="Text 13"/>
+          <p:cNvSpPr/>
+          <p:nvPr/>
+        </p:nvSpPr>
+        <p:spPr>
+          <a:xfrm>
+            <a:off x="1965960" y="3557016"/>
+            <a:ext cx="6720840" cy="274320"/>
+          </a:xfrm>
+          <a:prstGeom prst="rect">
+            <a:avLst/>
+          </a:prstGeom>
+          <a:noFill/>
+          <a:ln/>
+        </p:spPr>
+        <p:txBody>
+          <a:bodyPr wrap="square" lIns="0" tIns="0" rIns="0" bIns="0" rtlCol="0" anchor="t"/>
+          <a:lstStyle/>
+          <a:p>
+            <a:pPr indent="0" marL="0">
+              <a:buNone/>
+            </a:pPr>
+            <a:r>
+              <a:rPr lang="en-US" sz="1400" dirty="0">
                 <a:solidFill>
                   <a:srgbClr val="202B2D"/>
                 </a:solidFill>
@@ -5462,38 +6053,38 @@
                 <a:ea typeface="Arial" pitchFamily="34" charset="-122"/>
                 <a:cs typeface="Arial" pitchFamily="34" charset="-120"/>
               </a:rPr>
-              <a:t>Learning-based attackers</a:t>
-            </a:r>
-            <a:endParaRPr lang="en-US" sz="1900" dirty="0"/>
-          </a:p>
-        </p:txBody>
-      </p:sp>
-      <p:sp>
-        <p:nvSpPr>
-          <p:cNvPr id="9" name="Text 7"/>
-          <p:cNvSpPr/>
-          <p:nvPr/>
-        </p:nvSpPr>
-        <p:spPr>
-          <a:xfrm>
-            <a:off x="4617720" y="1371600"/>
-            <a:ext cx="4069080" cy="640080"/>
-          </a:xfrm>
-          <a:prstGeom prst="rect">
-            <a:avLst/>
-          </a:prstGeom>
-          <a:noFill/>
-          <a:ln/>
-        </p:spPr>
-        <p:txBody>
-          <a:bodyPr wrap="square" lIns="0" tIns="0" rIns="0" bIns="0" rtlCol="0" anchor="t"/>
-          <a:lstStyle/>
-          <a:p>
-            <a:pPr indent="0" marL="0">
-              <a:buNone/>
-            </a:pPr>
-            <a:r>
-              <a:rPr lang="en-US" sz="2300" b="1" dirty="0">
+              <a:t>An attacker-training workload label, not proven detector holdout.</a:t>
+            </a:r>
+            <a:endParaRPr lang="en-US" sz="1400" dirty="0"/>
+          </a:p>
+        </p:txBody>
+      </p:sp>
+      <p:sp>
+        <p:nvSpPr>
+          <p:cNvPr id="16" name="Text 14"/>
+          <p:cNvSpPr/>
+          <p:nvPr/>
+        </p:nvSpPr>
+        <p:spPr>
+          <a:xfrm>
+            <a:off x="457200" y="3895344"/>
+            <a:ext cx="1463040" cy="274320"/>
+          </a:xfrm>
+          <a:prstGeom prst="rect">
+            <a:avLst/>
+          </a:prstGeom>
+          <a:noFill/>
+          <a:ln/>
+        </p:spPr>
+        <p:txBody>
+          <a:bodyPr wrap="square" lIns="0" tIns="0" rIns="0" bIns="0" rtlCol="0" anchor="t"/>
+          <a:lstStyle/>
+          <a:p>
+            <a:pPr indent="0" marL="0">
+              <a:buNone/>
+            </a:pPr>
+            <a:r>
+              <a:rPr lang="en-US" sz="1300" b="1" dirty="0">
                 <a:solidFill>
                   <a:srgbClr val="01696F"/>
                 </a:solidFill>
@@ -5501,38 +6092,38 @@
                 <a:ea typeface="Arial" pitchFamily="34" charset="-122"/>
                 <a:cs typeface="Arial" pitchFamily="34" charset="-120"/>
               </a:rPr>
-              <a:t>Our implemented combination</a:t>
-            </a:r>
-            <a:endParaRPr lang="en-US" sz="2300" dirty="0"/>
-          </a:p>
-        </p:txBody>
-      </p:sp>
-      <p:sp>
-        <p:nvSpPr>
-          <p:cNvPr id="10" name="Text 8"/>
-          <p:cNvSpPr/>
-          <p:nvPr/>
-        </p:nvSpPr>
-        <p:spPr>
-          <a:xfrm>
-            <a:off x="4617720" y="2194560"/>
-            <a:ext cx="4069080" cy="1508760"/>
-          </a:xfrm>
-          <a:prstGeom prst="rect">
-            <a:avLst/>
-          </a:prstGeom>
-          <a:noFill/>
-          <a:ln/>
-        </p:spPr>
-        <p:txBody>
-          <a:bodyPr wrap="square" lIns="0" tIns="0" rIns="0" bIns="0" rtlCol="0" anchor="t"/>
-          <a:lstStyle/>
-          <a:p>
-            <a:pPr indent="0" marL="0">
-              <a:buNone/>
-            </a:pPr>
-            <a:r>
-              <a:rPr lang="en-US" sz="1900" dirty="0">
+              <a:t>Interpretation</a:t>
+            </a:r>
+            <a:endParaRPr lang="en-US" sz="1300" dirty="0"/>
+          </a:p>
+        </p:txBody>
+      </p:sp>
+      <p:sp>
+        <p:nvSpPr>
+          <p:cNvPr id="17" name="Text 15"/>
+          <p:cNvSpPr/>
+          <p:nvPr/>
+        </p:nvSpPr>
+        <p:spPr>
+          <a:xfrm>
+            <a:off x="1965960" y="3895344"/>
+            <a:ext cx="6720840" cy="274320"/>
+          </a:xfrm>
+          <a:prstGeom prst="rect">
+            <a:avLst/>
+          </a:prstGeom>
+          <a:noFill/>
+          <a:ln/>
+        </p:spPr>
+        <p:txBody>
+          <a:bodyPr wrap="square" lIns="0" tIns="0" rIns="0" bIns="0" rtlCol="0" anchor="t"/>
+          <a:lstStyle/>
+          <a:p>
+            <a:pPr indent="0" marL="0">
+              <a:buNone/>
+            </a:pPr>
+            <a:r>
+              <a:rPr lang="en-US" sz="1400" dirty="0">
                 <a:solidFill>
                   <a:srgbClr val="202B2D"/>
                 </a:solidFill>
@@ -5540,99 +6131,9 @@
                 <a:ea typeface="Arial" pitchFamily="34" charset="-122"/>
                 <a:cs typeface="Arial" pitchFamily="34" charset="-120"/>
               </a:rPr>
-              <a:t>Campaign + ledger execution</a:t>
-            </a:r>
-            <a:endParaRPr lang="en-US" sz="1900" dirty="0"/>
-          </a:p>
-          <a:p>
-            <a:pPr indent="0" marL="0">
-              <a:buNone/>
-            </a:pPr>
-            <a:r>
-              <a:rPr lang="en-US" sz="1900" dirty="0">
-                <a:solidFill>
-                  <a:srgbClr val="202B2D"/>
-                </a:solidFill>
-                <a:latin typeface="Arial" pitchFamily="34" charset="0"/>
-                <a:ea typeface="Arial" pitchFamily="34" charset="-122"/>
-                <a:cs typeface="Arial" pitchFamily="34" charset="-120"/>
-              </a:rPr>
-              <a:t>Inspectable tabular policies</a:t>
-            </a:r>
-            <a:endParaRPr lang="en-US" sz="1900" dirty="0"/>
-          </a:p>
-          <a:p>
-            <a:pPr indent="0" marL="0">
-              <a:buNone/>
-            </a:pPr>
-            <a:r>
-              <a:rPr lang="en-US" sz="1900" dirty="0">
-                <a:solidFill>
-                  <a:srgbClr val="202B2D"/>
-                </a:solidFill>
-                <a:latin typeface="Arial" pitchFamily="34" charset="0"/>
-                <a:ea typeface="Arial" pitchFamily="34" charset="-122"/>
-                <a:cs typeface="Arial" pitchFamily="34" charset="-120"/>
-              </a:rPr>
-              <a:t>Saved checkpoints and raw traces</a:t>
-            </a:r>
-            <a:endParaRPr lang="en-US" sz="1900" dirty="0"/>
-          </a:p>
-          <a:p>
-            <a:pPr indent="0" marL="0">
-              <a:buNone/>
-            </a:pPr>
-            <a:r>
-              <a:rPr lang="en-US" sz="1900" dirty="0">
-                <a:solidFill>
-                  <a:srgbClr val="202B2D"/>
-                </a:solidFill>
-                <a:latin typeface="Arial" pitchFamily="34" charset="0"/>
-                <a:ea typeface="Arial" pitchFamily="34" charset="-122"/>
-                <a:cs typeface="Arial" pitchFamily="34" charset="-120"/>
-              </a:rPr>
-              <a:t>Reproducible comparisons</a:t>
-            </a:r>
-            <a:endParaRPr lang="en-US" sz="1900" dirty="0"/>
-          </a:p>
-        </p:txBody>
-      </p:sp>
-      <p:sp>
-        <p:nvSpPr>
-          <p:cNvPr id="11" name="Text 9"/>
-          <p:cNvSpPr/>
-          <p:nvPr/>
-        </p:nvSpPr>
-        <p:spPr>
-          <a:xfrm>
-            <a:off x="457200" y="3977640"/>
-            <a:ext cx="8229600" cy="320040"/>
-          </a:xfrm>
-          <a:prstGeom prst="rect">
-            <a:avLst/>
-          </a:prstGeom>
-          <a:noFill/>
-          <a:ln/>
-        </p:spPr>
-        <p:txBody>
-          <a:bodyPr wrap="square" lIns="0" tIns="0" rIns="0" bIns="0" rtlCol="0" anchor="t"/>
-          <a:lstStyle/>
-          <a:p>
-            <a:pPr indent="0" marL="0">
-              <a:buNone/>
-            </a:pPr>
-            <a:r>
-              <a:rPr lang="en-US" sz="1500" dirty="0">
-                <a:solidFill>
-                  <a:srgbClr val="202B2D"/>
-                </a:solidFill>
-                <a:latin typeface="Arial" pitchFamily="34" charset="0"/>
-                <a:ea typeface="Arial" pitchFamily="34" charset="-122"/>
-                <a:cs typeface="Arial" pitchFamily="34" charset="-120"/>
-              </a:rPr>
-              <a:t>Useful research infrastructure, not a first-ever algorithm or superiority claim.</a:t>
-            </a:r>
-            <a:endParaRPr lang="en-US" sz="1500" dirty="0"/>
+              <a:t>A tiny demo proves execution, not RL superiority or money saved.</a:t>
+            </a:r>
+            <a:endParaRPr lang="en-US" sz="1400" dirty="0"/>
           </a:p>
         </p:txBody>
       </p:sp>
@@ -6163,7 +6664,7 @@
                 <a:ea typeface="Arial" pitchFamily="34" charset="-122"/>
                 <a:cs typeface="Arial" pitchFamily="34" charset="-120"/>
               </a:rPr>
-              <a:t>What we can defend at review</a:t>
+              <a:t>From master to our final prototype</a:t>
             </a:r>
             <a:endParaRPr lang="en-US" sz="3400" dirty="0"/>
           </a:p>
@@ -6325,38 +6826,1099 @@
                   </a:extLst>
                 </a:hlinkClick>
               </a:rPr>
-              <a:t>prototype source and retained records</a:t>
+              <a:t>verified master-to-prototype code comparison</a:t>
             </a:r>
             <a:endParaRPr lang="en-US" sz="1000" dirty="0"/>
           </a:p>
         </p:txBody>
       </p:sp>
-      <p:sp>
-        <p:nvSpPr>
-          <p:cNvPr id="7" name="Text 5"/>
-          <p:cNvSpPr/>
-          <p:nvPr/>
-        </p:nvSpPr>
-        <p:spPr>
-          <a:xfrm>
-            <a:off x="457200" y="1371600"/>
-            <a:ext cx="2286000" cy="365760"/>
-          </a:xfrm>
-          <a:prstGeom prst="rect">
-            <a:avLst/>
-          </a:prstGeom>
-          <a:noFill/>
-          <a:ln/>
-        </p:spPr>
-        <p:txBody>
-          <a:bodyPr wrap="square" lIns="0" tIns="0" rIns="0" bIns="0" rtlCol="0" anchor="t"/>
-          <a:lstStyle/>
-          <a:p>
-            <a:pPr indent="0" marL="0">
-              <a:buNone/>
-            </a:pPr>
-            <a:r>
-              <a:rPr lang="en-US" sz="2000" b="1" dirty="0">
+      <p:graphicFrame>
+        <p:nvGraphicFramePr>
+          <p:cNvPr id="9" name="Table 0"/>
+          <p:cNvGraphicFramePr>
+            <a:graphicFrameLocks noGrp="1"/>
+          </p:cNvGraphicFramePr>
+          <p:nvPr>
+            <p:extLst>
+              <p:ext uri="{D42A27DB-BD31-4B8C-83A1-F6EECF244321}">
+                <p14:modId xmlns:p14="http://schemas.microsoft.com/office/powerpoint/2010/main" val="1579011935"/>
+              </p:ext>
+            </p:extLst>
+          </p:nvPr>
+        </p:nvGraphicFramePr>
+        <p:xfrm>
+          <a:off x="457200" y="1280160"/>
+          <a:ext cx="8229600" cy="914400"/>
+        </p:xfrm>
+        <a:graphic>
+          <a:graphicData uri="http://schemas.openxmlformats.org/drawingml/2006/table">
+            <a:tbl>
+              <a:tblPr/>
+              <a:tblGrid>
+                <a:gridCol w="1325880"/>
+                <a:gridCol w="2880360"/>
+                <a:gridCol w="4023360"/>
+              </a:tblGrid>
+              <a:tr h="438912">
+                <a:tc>
+                  <a:txBody>
+                    <a:bodyPr/>
+                    <a:lstStyle/>
+                    <a:p>
+                      <a:pPr indent="0" marL="0">
+                        <a:buNone/>
+                      </a:pPr>
+                      <a:r>
+                        <a:rPr lang="en-US" sz="1400" b="1" dirty="0">
+                          <a:solidFill>
+                            <a:srgbClr val="FFFFFF"/>
+                          </a:solidFill>
+                          <a:latin typeface="Arial" pitchFamily="34" charset="0"/>
+                          <a:ea typeface="Arial" pitchFamily="34" charset="-122"/>
+                          <a:cs typeface="Arial" pitchFamily="34" charset="-120"/>
+                        </a:rPr>
+                        <a:t>Area</a:t>
+                      </a:r>
+                      <a:endParaRPr lang="en-US" sz="1400" dirty="0">
+                        <a:latin typeface="Arial" charset="0"/>
+                        <a:ea typeface="Arial" charset="0"/>
+                        <a:cs typeface="Arial" charset="0"/>
+                      </a:endParaRPr>
+                    </a:p>
+                  </a:txBody>
+                  <a:tcPr marL="82296" marR="82296" marT="82296" marB="82296" anchor="ctr">
+                    <a:lnL w="6350" cap="flat" cmpd="sng" algn="ctr">
+                      <a:solidFill>
+                        <a:srgbClr val="D7E0DE"/>
+                      </a:solidFill>
+                      <a:prstDash val="solid"/>
+                      <a:round/>
+                      <a:headEnd type="none" w="med" len="med"/>
+                      <a:tailEnd type="none" w="med" len="med"/>
+                    </a:lnL>
+                    <a:lnR w="6350" cap="flat" cmpd="sng" algn="ctr">
+                      <a:solidFill>
+                        <a:srgbClr val="D7E0DE"/>
+                      </a:solidFill>
+                      <a:prstDash val="solid"/>
+                      <a:round/>
+                      <a:headEnd type="none" w="med" len="med"/>
+                      <a:tailEnd type="none" w="med" len="med"/>
+                    </a:lnR>
+                    <a:lnT w="6350" cap="flat" cmpd="sng" algn="ctr">
+                      <a:solidFill>
+                        <a:srgbClr val="D7E0DE"/>
+                      </a:solidFill>
+                      <a:prstDash val="solid"/>
+                      <a:round/>
+                      <a:headEnd type="none" w="med" len="med"/>
+                      <a:tailEnd type="none" w="med" len="med"/>
+                    </a:lnT>
+                    <a:lnB w="6350" cap="flat" cmpd="sng" algn="ctr">
+                      <a:solidFill>
+                        <a:srgbClr val="D7E0DE"/>
+                      </a:solidFill>
+                      <a:prstDash val="solid"/>
+                      <a:round/>
+                      <a:headEnd type="none" w="med" len="med"/>
+                      <a:tailEnd type="none" w="med" len="med"/>
+                    </a:lnB>
+                    <a:solidFill>
+                      <a:srgbClr val="01696F"/>
+                    </a:solidFill>
+                  </a:tcPr>
+                </a:tc>
+                <a:tc>
+                  <a:txBody>
+                    <a:bodyPr/>
+                    <a:lstStyle/>
+                    <a:p>
+                      <a:pPr indent="0" marL="0">
+                        <a:buNone/>
+                      </a:pPr>
+                      <a:r>
+                        <a:rPr lang="en-US" sz="1400" b="1" dirty="0">
+                          <a:solidFill>
+                            <a:srgbClr val="FFFFFF"/>
+                          </a:solidFill>
+                          <a:latin typeface="Arial" pitchFamily="34" charset="0"/>
+                          <a:ea typeface="Arial" pitchFamily="34" charset="-122"/>
+                          <a:cs typeface="Arial" pitchFamily="34" charset="-120"/>
+                        </a:rPr>
+                        <a:t>master: earlier baseline</a:t>
+                      </a:r>
+                      <a:endParaRPr lang="en-US" sz="1400" dirty="0">
+                        <a:latin typeface="Arial" charset="0"/>
+                        <a:ea typeface="Arial" charset="0"/>
+                        <a:cs typeface="Arial" charset="0"/>
+                      </a:endParaRPr>
+                    </a:p>
+                  </a:txBody>
+                  <a:tcPr marL="82296" marR="82296" marT="82296" marB="82296" anchor="ctr">
+                    <a:lnL w="6350" cap="flat" cmpd="sng" algn="ctr">
+                      <a:solidFill>
+                        <a:srgbClr val="D7E0DE"/>
+                      </a:solidFill>
+                      <a:prstDash val="solid"/>
+                      <a:round/>
+                      <a:headEnd type="none" w="med" len="med"/>
+                      <a:tailEnd type="none" w="med" len="med"/>
+                    </a:lnL>
+                    <a:lnR w="6350" cap="flat" cmpd="sng" algn="ctr">
+                      <a:solidFill>
+                        <a:srgbClr val="D7E0DE"/>
+                      </a:solidFill>
+                      <a:prstDash val="solid"/>
+                      <a:round/>
+                      <a:headEnd type="none" w="med" len="med"/>
+                      <a:tailEnd type="none" w="med" len="med"/>
+                    </a:lnR>
+                    <a:lnT w="6350" cap="flat" cmpd="sng" algn="ctr">
+                      <a:solidFill>
+                        <a:srgbClr val="D7E0DE"/>
+                      </a:solidFill>
+                      <a:prstDash val="solid"/>
+                      <a:round/>
+                      <a:headEnd type="none" w="med" len="med"/>
+                      <a:tailEnd type="none" w="med" len="med"/>
+                    </a:lnT>
+                    <a:lnB w="6350" cap="flat" cmpd="sng" algn="ctr">
+                      <a:solidFill>
+                        <a:srgbClr val="D7E0DE"/>
+                      </a:solidFill>
+                      <a:prstDash val="solid"/>
+                      <a:round/>
+                      <a:headEnd type="none" w="med" len="med"/>
+                      <a:tailEnd type="none" w="med" len="med"/>
+                    </a:lnB>
+                    <a:solidFill>
+                      <a:srgbClr val="01696F"/>
+                    </a:solidFill>
+                  </a:tcPr>
+                </a:tc>
+                <a:tc>
+                  <a:txBody>
+                    <a:bodyPr/>
+                    <a:lstStyle/>
+                    <a:p>
+                      <a:pPr indent="0" marL="0">
+                        <a:buNone/>
+                      </a:pPr>
+                      <a:r>
+                        <a:rPr lang="en-US" sz="1400" b="1" dirty="0">
+                          <a:solidFill>
+                            <a:srgbClr val="FFFFFF"/>
+                          </a:solidFill>
+                          <a:latin typeface="Arial" pitchFamily="34" charset="0"/>
+                          <a:ea typeface="Arial" pitchFamily="34" charset="-122"/>
+                          <a:cs typeface="Arial" pitchFamily="34" charset="-120"/>
+                        </a:rPr>
+                        <a:t>prototype: selected FINAL</a:t>
+                      </a:r>
+                      <a:endParaRPr lang="en-US" sz="1400" dirty="0">
+                        <a:latin typeface="Arial" charset="0"/>
+                        <a:ea typeface="Arial" charset="0"/>
+                        <a:cs typeface="Arial" charset="0"/>
+                      </a:endParaRPr>
+                    </a:p>
+                  </a:txBody>
+                  <a:tcPr marL="82296" marR="82296" marT="82296" marB="82296" anchor="ctr">
+                    <a:lnL w="6350" cap="flat" cmpd="sng" algn="ctr">
+                      <a:solidFill>
+                        <a:srgbClr val="D7E0DE"/>
+                      </a:solidFill>
+                      <a:prstDash val="solid"/>
+                      <a:round/>
+                      <a:headEnd type="none" w="med" len="med"/>
+                      <a:tailEnd type="none" w="med" len="med"/>
+                    </a:lnL>
+                    <a:lnR w="6350" cap="flat" cmpd="sng" algn="ctr">
+                      <a:solidFill>
+                        <a:srgbClr val="D7E0DE"/>
+                      </a:solidFill>
+                      <a:prstDash val="solid"/>
+                      <a:round/>
+                      <a:headEnd type="none" w="med" len="med"/>
+                      <a:tailEnd type="none" w="med" len="med"/>
+                    </a:lnR>
+                    <a:lnT w="6350" cap="flat" cmpd="sng" algn="ctr">
+                      <a:solidFill>
+                        <a:srgbClr val="D7E0DE"/>
+                      </a:solidFill>
+                      <a:prstDash val="solid"/>
+                      <a:round/>
+                      <a:headEnd type="none" w="med" len="med"/>
+                      <a:tailEnd type="none" w="med" len="med"/>
+                    </a:lnT>
+                    <a:lnB w="6350" cap="flat" cmpd="sng" algn="ctr">
+                      <a:solidFill>
+                        <a:srgbClr val="D7E0DE"/>
+                      </a:solidFill>
+                      <a:prstDash val="solid"/>
+                      <a:round/>
+                      <a:headEnd type="none" w="med" len="med"/>
+                      <a:tailEnd type="none" w="med" len="med"/>
+                    </a:lnB>
+                    <a:solidFill>
+                      <a:srgbClr val="01696F"/>
+                    </a:solidFill>
+                  </a:tcPr>
+                </a:tc>
+              </a:tr>
+              <a:tr h="438912">
+                <a:tc>
+                  <a:txBody>
+                    <a:bodyPr/>
+                    <a:lstStyle/>
+                    <a:p>
+                      <a:pPr indent="0" marL="0">
+                        <a:buNone/>
+                      </a:pPr>
+                      <a:r>
+                        <a:rPr lang="en-US" sz="1400" dirty="0">
+                          <a:solidFill>
+                            <a:srgbClr val="172D30"/>
+                          </a:solidFill>
+                          <a:latin typeface="Arial" pitchFamily="34" charset="0"/>
+                          <a:ea typeface="Arial" pitchFamily="34" charset="-122"/>
+                          <a:cs typeface="Arial" pitchFamily="34" charset="-120"/>
+                        </a:rPr>
+                        <a:t>Learning</a:t>
+                      </a:r>
+                      <a:endParaRPr lang="en-US" sz="1400" dirty="0">
+                        <a:latin typeface="Arial" charset="0"/>
+                        <a:ea typeface="Arial" charset="0"/>
+                        <a:cs typeface="Arial" charset="0"/>
+                      </a:endParaRPr>
+                    </a:p>
+                  </a:txBody>
+                  <a:tcPr marL="82296" marR="82296" marT="82296" marB="82296" anchor="ctr">
+                    <a:lnL w="6350" cap="flat" cmpd="sng" algn="ctr">
+                      <a:solidFill>
+                        <a:srgbClr val="D7E0DE"/>
+                      </a:solidFill>
+                      <a:prstDash val="solid"/>
+                      <a:round/>
+                      <a:headEnd type="none" w="med" len="med"/>
+                      <a:tailEnd type="none" w="med" len="med"/>
+                    </a:lnL>
+                    <a:lnR w="6350" cap="flat" cmpd="sng" algn="ctr">
+                      <a:solidFill>
+                        <a:srgbClr val="D7E0DE"/>
+                      </a:solidFill>
+                      <a:prstDash val="solid"/>
+                      <a:round/>
+                      <a:headEnd type="none" w="med" len="med"/>
+                      <a:tailEnd type="none" w="med" len="med"/>
+                    </a:lnR>
+                    <a:lnT w="6350" cap="flat" cmpd="sng" algn="ctr">
+                      <a:solidFill>
+                        <a:srgbClr val="D7E0DE"/>
+                      </a:solidFill>
+                      <a:prstDash val="solid"/>
+                      <a:round/>
+                      <a:headEnd type="none" w="med" len="med"/>
+                      <a:tailEnd type="none" w="med" len="med"/>
+                    </a:lnT>
+                    <a:lnB w="6350" cap="flat" cmpd="sng" algn="ctr">
+                      <a:solidFill>
+                        <a:srgbClr val="D7E0DE"/>
+                      </a:solidFill>
+                      <a:prstDash val="solid"/>
+                      <a:round/>
+                      <a:headEnd type="none" w="med" len="med"/>
+                      <a:tailEnd type="none" w="med" len="med"/>
+                    </a:lnB>
+                    <a:solidFill>
+                      <a:srgbClr val="FFFFFF"/>
+                    </a:solidFill>
+                  </a:tcPr>
+                </a:tc>
+                <a:tc>
+                  <a:txBody>
+                    <a:bodyPr/>
+                    <a:lstStyle/>
+                    <a:p>
+                      <a:pPr indent="0" marL="0">
+                        <a:buNone/>
+                      </a:pPr>
+                      <a:r>
+                        <a:rPr lang="en-US" sz="1400" dirty="0">
+                          <a:solidFill>
+                            <a:srgbClr val="172D30"/>
+                          </a:solidFill>
+                          <a:latin typeface="Arial" pitchFamily="34" charset="0"/>
+                          <a:ea typeface="Arial" pitchFamily="34" charset="-122"/>
+                          <a:cs typeface="Arial" pitchFamily="34" charset="-120"/>
+                        </a:rPr>
+                        <a:t>Static + rule policies</a:t>
+                      </a:r>
+                      <a:endParaRPr lang="en-US" sz="1400" dirty="0">
+                        <a:latin typeface="Arial" charset="0"/>
+                        <a:ea typeface="Arial" charset="0"/>
+                        <a:cs typeface="Arial" charset="0"/>
+                      </a:endParaRPr>
+                    </a:p>
+                  </a:txBody>
+                  <a:tcPr marL="82296" marR="82296" marT="82296" marB="82296" anchor="ctr">
+                    <a:lnL w="6350" cap="flat" cmpd="sng" algn="ctr">
+                      <a:solidFill>
+                        <a:srgbClr val="D7E0DE"/>
+                      </a:solidFill>
+                      <a:prstDash val="solid"/>
+                      <a:round/>
+                      <a:headEnd type="none" w="med" len="med"/>
+                      <a:tailEnd type="none" w="med" len="med"/>
+                    </a:lnL>
+                    <a:lnR w="6350" cap="flat" cmpd="sng" algn="ctr">
+                      <a:solidFill>
+                        <a:srgbClr val="D7E0DE"/>
+                      </a:solidFill>
+                      <a:prstDash val="solid"/>
+                      <a:round/>
+                      <a:headEnd type="none" w="med" len="med"/>
+                      <a:tailEnd type="none" w="med" len="med"/>
+                    </a:lnR>
+                    <a:lnT w="6350" cap="flat" cmpd="sng" algn="ctr">
+                      <a:solidFill>
+                        <a:srgbClr val="D7E0DE"/>
+                      </a:solidFill>
+                      <a:prstDash val="solid"/>
+                      <a:round/>
+                      <a:headEnd type="none" w="med" len="med"/>
+                      <a:tailEnd type="none" w="med" len="med"/>
+                    </a:lnT>
+                    <a:lnB w="6350" cap="flat" cmpd="sng" algn="ctr">
+                      <a:solidFill>
+                        <a:srgbClr val="D7E0DE"/>
+                      </a:solidFill>
+                      <a:prstDash val="solid"/>
+                      <a:round/>
+                      <a:headEnd type="none" w="med" len="med"/>
+                      <a:tailEnd type="none" w="med" len="med"/>
+                    </a:lnB>
+                    <a:solidFill>
+                      <a:srgbClr val="FFFFFF"/>
+                    </a:solidFill>
+                  </a:tcPr>
+                </a:tc>
+                <a:tc>
+                  <a:txBody>
+                    <a:bodyPr/>
+                    <a:lstStyle/>
+                    <a:p>
+                      <a:pPr indent="0" marL="0">
+                        <a:buNone/>
+                      </a:pPr>
+                      <a:r>
+                        <a:rPr lang="en-US" sz="1400" dirty="0">
+                          <a:solidFill>
+                            <a:srgbClr val="172D30"/>
+                          </a:solidFill>
+                          <a:latin typeface="Arial" pitchFamily="34" charset="0"/>
+                          <a:ea typeface="Arial" pitchFamily="34" charset="-122"/>
+                          <a:cs typeface="Arial" pitchFamily="34" charset="-120"/>
+                        </a:rPr>
+                        <a:t>Adds Q-learning + zero-Q control</a:t>
+                      </a:r>
+                      <a:endParaRPr lang="en-US" sz="1400" dirty="0">
+                        <a:latin typeface="Arial" charset="0"/>
+                        <a:ea typeface="Arial" charset="0"/>
+                        <a:cs typeface="Arial" charset="0"/>
+                      </a:endParaRPr>
+                    </a:p>
+                  </a:txBody>
+                  <a:tcPr marL="82296" marR="82296" marT="82296" marB="82296" anchor="ctr">
+                    <a:lnL w="6350" cap="flat" cmpd="sng" algn="ctr">
+                      <a:solidFill>
+                        <a:srgbClr val="D7E0DE"/>
+                      </a:solidFill>
+                      <a:prstDash val="solid"/>
+                      <a:round/>
+                      <a:headEnd type="none" w="med" len="med"/>
+                      <a:tailEnd type="none" w="med" len="med"/>
+                    </a:lnL>
+                    <a:lnR w="6350" cap="flat" cmpd="sng" algn="ctr">
+                      <a:solidFill>
+                        <a:srgbClr val="D7E0DE"/>
+                      </a:solidFill>
+                      <a:prstDash val="solid"/>
+                      <a:round/>
+                      <a:headEnd type="none" w="med" len="med"/>
+                      <a:tailEnd type="none" w="med" len="med"/>
+                    </a:lnR>
+                    <a:lnT w="6350" cap="flat" cmpd="sng" algn="ctr">
+                      <a:solidFill>
+                        <a:srgbClr val="D7E0DE"/>
+                      </a:solidFill>
+                      <a:prstDash val="solid"/>
+                      <a:round/>
+                      <a:headEnd type="none" w="med" len="med"/>
+                      <a:tailEnd type="none" w="med" len="med"/>
+                    </a:lnT>
+                    <a:lnB w="6350" cap="flat" cmpd="sng" algn="ctr">
+                      <a:solidFill>
+                        <a:srgbClr val="D7E0DE"/>
+                      </a:solidFill>
+                      <a:prstDash val="solid"/>
+                      <a:round/>
+                      <a:headEnd type="none" w="med" len="med"/>
+                      <a:tailEnd type="none" w="med" len="med"/>
+                    </a:lnB>
+                    <a:solidFill>
+                      <a:srgbClr val="FFFFFF"/>
+                    </a:solidFill>
+                  </a:tcPr>
+                </a:tc>
+              </a:tr>
+              <a:tr h="438912">
+                <a:tc>
+                  <a:txBody>
+                    <a:bodyPr/>
+                    <a:lstStyle/>
+                    <a:p>
+                      <a:pPr indent="0" marL="0">
+                        <a:buNone/>
+                      </a:pPr>
+                      <a:r>
+                        <a:rPr lang="en-US" sz="1400" dirty="0">
+                          <a:solidFill>
+                            <a:srgbClr val="172D30"/>
+                          </a:solidFill>
+                          <a:latin typeface="Arial" pitchFamily="34" charset="0"/>
+                          <a:ea typeface="Arial" pitchFamily="34" charset="-122"/>
+                          <a:cs typeface="Arial" pitchFamily="34" charset="-120"/>
+                        </a:rPr>
+                        <a:t>Run / reload</a:t>
+                      </a:r>
+                      <a:endParaRPr lang="en-US" sz="1400" dirty="0">
+                        <a:latin typeface="Arial" charset="0"/>
+                        <a:ea typeface="Arial" charset="0"/>
+                        <a:cs typeface="Arial" charset="0"/>
+                      </a:endParaRPr>
+                    </a:p>
+                  </a:txBody>
+                  <a:tcPr marL="82296" marR="82296" marT="82296" marB="82296" anchor="ctr">
+                    <a:lnL w="6350" cap="flat" cmpd="sng" algn="ctr">
+                      <a:solidFill>
+                        <a:srgbClr val="D7E0DE"/>
+                      </a:solidFill>
+                      <a:prstDash val="solid"/>
+                      <a:round/>
+                      <a:headEnd type="none" w="med" len="med"/>
+                      <a:tailEnd type="none" w="med" len="med"/>
+                    </a:lnL>
+                    <a:lnR w="6350" cap="flat" cmpd="sng" algn="ctr">
+                      <a:solidFill>
+                        <a:srgbClr val="D7E0DE"/>
+                      </a:solidFill>
+                      <a:prstDash val="solid"/>
+                      <a:round/>
+                      <a:headEnd type="none" w="med" len="med"/>
+                      <a:tailEnd type="none" w="med" len="med"/>
+                    </a:lnR>
+                    <a:lnT w="6350" cap="flat" cmpd="sng" algn="ctr">
+                      <a:solidFill>
+                        <a:srgbClr val="D7E0DE"/>
+                      </a:solidFill>
+                      <a:prstDash val="solid"/>
+                      <a:round/>
+                      <a:headEnd type="none" w="med" len="med"/>
+                      <a:tailEnd type="none" w="med" len="med"/>
+                    </a:lnT>
+                    <a:lnB w="6350" cap="flat" cmpd="sng" algn="ctr">
+                      <a:solidFill>
+                        <a:srgbClr val="D7E0DE"/>
+                      </a:solidFill>
+                      <a:prstDash val="solid"/>
+                      <a:round/>
+                      <a:headEnd type="none" w="med" len="med"/>
+                      <a:tailEnd type="none" w="med" len="med"/>
+                    </a:lnB>
+                    <a:solidFill>
+                      <a:srgbClr val="FFFFFF"/>
+                    </a:solidFill>
+                  </a:tcPr>
+                </a:tc>
+                <a:tc>
+                  <a:txBody>
+                    <a:bodyPr/>
+                    <a:lstStyle/>
+                    <a:p>
+                      <a:pPr indent="0" marL="0">
+                        <a:buNone/>
+                      </a:pPr>
+                      <a:r>
+                        <a:rPr lang="en-US" sz="1400" dirty="0">
+                          <a:solidFill>
+                            <a:srgbClr val="172D30"/>
+                          </a:solidFill>
+                          <a:latin typeface="Arial" pitchFamily="34" charset="0"/>
+                          <a:ea typeface="Arial" pitchFamily="34" charset="-122"/>
+                          <a:cs typeface="Arial" pitchFamily="34" charset="-120"/>
+                        </a:rPr>
+                        <a:t>Scenario runner</a:t>
+                      </a:r>
+                      <a:endParaRPr lang="en-US" sz="1400" dirty="0">
+                        <a:latin typeface="Arial" charset="0"/>
+                        <a:ea typeface="Arial" charset="0"/>
+                        <a:cs typeface="Arial" charset="0"/>
+                      </a:endParaRPr>
+                    </a:p>
+                  </a:txBody>
+                  <a:tcPr marL="82296" marR="82296" marT="82296" marB="82296" anchor="ctr">
+                    <a:lnL w="6350" cap="flat" cmpd="sng" algn="ctr">
+                      <a:solidFill>
+                        <a:srgbClr val="D7E0DE"/>
+                      </a:solidFill>
+                      <a:prstDash val="solid"/>
+                      <a:round/>
+                      <a:headEnd type="none" w="med" len="med"/>
+                      <a:tailEnd type="none" w="med" len="med"/>
+                    </a:lnL>
+                    <a:lnR w="6350" cap="flat" cmpd="sng" algn="ctr">
+                      <a:solidFill>
+                        <a:srgbClr val="D7E0DE"/>
+                      </a:solidFill>
+                      <a:prstDash val="solid"/>
+                      <a:round/>
+                      <a:headEnd type="none" w="med" len="med"/>
+                      <a:tailEnd type="none" w="med" len="med"/>
+                    </a:lnR>
+                    <a:lnT w="6350" cap="flat" cmpd="sng" algn="ctr">
+                      <a:solidFill>
+                        <a:srgbClr val="D7E0DE"/>
+                      </a:solidFill>
+                      <a:prstDash val="solid"/>
+                      <a:round/>
+                      <a:headEnd type="none" w="med" len="med"/>
+                      <a:tailEnd type="none" w="med" len="med"/>
+                    </a:lnT>
+                    <a:lnB w="6350" cap="flat" cmpd="sng" algn="ctr">
+                      <a:solidFill>
+                        <a:srgbClr val="D7E0DE"/>
+                      </a:solidFill>
+                      <a:prstDash val="solid"/>
+                      <a:round/>
+                      <a:headEnd type="none" w="med" len="med"/>
+                      <a:tailEnd type="none" w="med" len="med"/>
+                    </a:lnB>
+                    <a:solidFill>
+                      <a:srgbClr val="FFFFFF"/>
+                    </a:solidFill>
+                  </a:tcPr>
+                </a:tc>
+                <a:tc>
+                  <a:txBody>
+                    <a:bodyPr/>
+                    <a:lstStyle/>
+                    <a:p>
+                      <a:pPr indent="0" marL="0">
+                        <a:buNone/>
+                      </a:pPr>
+                      <a:r>
+                        <a:rPr lang="en-US" sz="1400" dirty="0">
+                          <a:solidFill>
+                            <a:srgbClr val="172D30"/>
+                          </a:solidFill>
+                          <a:latin typeface="Arial" pitchFamily="34" charset="0"/>
+                          <a:ea typeface="Arial" pitchFamily="34" charset="-122"/>
+                          <a:cs typeface="Arial" pitchFamily="34" charset="-120"/>
+                        </a:rPr>
+                        <a:t>RL runner + saved-policy evaluation</a:t>
+                      </a:r>
+                      <a:endParaRPr lang="en-US" sz="1400" dirty="0">
+                        <a:latin typeface="Arial" charset="0"/>
+                        <a:ea typeface="Arial" charset="0"/>
+                        <a:cs typeface="Arial" charset="0"/>
+                      </a:endParaRPr>
+                    </a:p>
+                  </a:txBody>
+                  <a:tcPr marL="82296" marR="82296" marT="82296" marB="82296" anchor="ctr">
+                    <a:lnL w="6350" cap="flat" cmpd="sng" algn="ctr">
+                      <a:solidFill>
+                        <a:srgbClr val="D7E0DE"/>
+                      </a:solidFill>
+                      <a:prstDash val="solid"/>
+                      <a:round/>
+                      <a:headEnd type="none" w="med" len="med"/>
+                      <a:tailEnd type="none" w="med" len="med"/>
+                    </a:lnL>
+                    <a:lnR w="6350" cap="flat" cmpd="sng" algn="ctr">
+                      <a:solidFill>
+                        <a:srgbClr val="D7E0DE"/>
+                      </a:solidFill>
+                      <a:prstDash val="solid"/>
+                      <a:round/>
+                      <a:headEnd type="none" w="med" len="med"/>
+                      <a:tailEnd type="none" w="med" len="med"/>
+                    </a:lnR>
+                    <a:lnT w="6350" cap="flat" cmpd="sng" algn="ctr">
+                      <a:solidFill>
+                        <a:srgbClr val="D7E0DE"/>
+                      </a:solidFill>
+                      <a:prstDash val="solid"/>
+                      <a:round/>
+                      <a:headEnd type="none" w="med" len="med"/>
+                      <a:tailEnd type="none" w="med" len="med"/>
+                    </a:lnT>
+                    <a:lnB w="6350" cap="flat" cmpd="sng" algn="ctr">
+                      <a:solidFill>
+                        <a:srgbClr val="D7E0DE"/>
+                      </a:solidFill>
+                      <a:prstDash val="solid"/>
+                      <a:round/>
+                      <a:headEnd type="none" w="med" len="med"/>
+                      <a:tailEnd type="none" w="med" len="med"/>
+                    </a:lnB>
+                    <a:solidFill>
+                      <a:srgbClr val="FFFFFF"/>
+                    </a:solidFill>
+                  </a:tcPr>
+                </a:tc>
+              </a:tr>
+              <a:tr h="438912">
+                <a:tc>
+                  <a:txBody>
+                    <a:bodyPr/>
+                    <a:lstStyle/>
+                    <a:p>
+                      <a:pPr indent="0" marL="0">
+                        <a:buNone/>
+                      </a:pPr>
+                      <a:r>
+                        <a:rPr lang="en-US" sz="1400" dirty="0">
+                          <a:solidFill>
+                            <a:srgbClr val="172D30"/>
+                          </a:solidFill>
+                          <a:latin typeface="Arial" pitchFamily="34" charset="0"/>
+                          <a:ea typeface="Arial" pitchFamily="34" charset="-122"/>
+                          <a:cs typeface="Arial" pitchFamily="34" charset="-120"/>
+                        </a:rPr>
+                        <a:t>Evidence</a:t>
+                      </a:r>
+                      <a:endParaRPr lang="en-US" sz="1400" dirty="0">
+                        <a:latin typeface="Arial" charset="0"/>
+                        <a:ea typeface="Arial" charset="0"/>
+                        <a:cs typeface="Arial" charset="0"/>
+                      </a:endParaRPr>
+                    </a:p>
+                  </a:txBody>
+                  <a:tcPr marL="82296" marR="82296" marT="82296" marB="82296" anchor="ctr">
+                    <a:lnL w="6350" cap="flat" cmpd="sng" algn="ctr">
+                      <a:solidFill>
+                        <a:srgbClr val="D7E0DE"/>
+                      </a:solidFill>
+                      <a:prstDash val="solid"/>
+                      <a:round/>
+                      <a:headEnd type="none" w="med" len="med"/>
+                      <a:tailEnd type="none" w="med" len="med"/>
+                    </a:lnL>
+                    <a:lnR w="6350" cap="flat" cmpd="sng" algn="ctr">
+                      <a:solidFill>
+                        <a:srgbClr val="D7E0DE"/>
+                      </a:solidFill>
+                      <a:prstDash val="solid"/>
+                      <a:round/>
+                      <a:headEnd type="none" w="med" len="med"/>
+                      <a:tailEnd type="none" w="med" len="med"/>
+                    </a:lnR>
+                    <a:lnT w="6350" cap="flat" cmpd="sng" algn="ctr">
+                      <a:solidFill>
+                        <a:srgbClr val="D7E0DE"/>
+                      </a:solidFill>
+                      <a:prstDash val="solid"/>
+                      <a:round/>
+                      <a:headEnd type="none" w="med" len="med"/>
+                      <a:tailEnd type="none" w="med" len="med"/>
+                    </a:lnT>
+                    <a:lnB w="6350" cap="flat" cmpd="sng" algn="ctr">
+                      <a:solidFill>
+                        <a:srgbClr val="D7E0DE"/>
+                      </a:solidFill>
+                      <a:prstDash val="solid"/>
+                      <a:round/>
+                      <a:headEnd type="none" w="med" len="med"/>
+                      <a:tailEnd type="none" w="med" len="med"/>
+                    </a:lnB>
+                    <a:solidFill>
+                      <a:srgbClr val="FFFFFF"/>
+                    </a:solidFill>
+                  </a:tcPr>
+                </a:tc>
+                <a:tc>
+                  <a:txBody>
+                    <a:bodyPr/>
+                    <a:lstStyle/>
+                    <a:p>
+                      <a:pPr indent="0" marL="0">
+                        <a:buNone/>
+                      </a:pPr>
+                      <a:r>
+                        <a:rPr lang="en-US" sz="1400" dirty="0">
+                          <a:solidFill>
+                            <a:srgbClr val="172D30"/>
+                          </a:solidFill>
+                          <a:latin typeface="Arial" pitchFamily="34" charset="0"/>
+                          <a:ea typeface="Arial" pitchFamily="34" charset="-122"/>
+                          <a:cs typeface="Arial" pitchFamily="34" charset="-120"/>
+                        </a:rPr>
+                        <a:t>Scenario summaries</a:t>
+                      </a:r>
+                      <a:endParaRPr lang="en-US" sz="1400" dirty="0">
+                        <a:latin typeface="Arial" charset="0"/>
+                        <a:ea typeface="Arial" charset="0"/>
+                        <a:cs typeface="Arial" charset="0"/>
+                      </a:endParaRPr>
+                    </a:p>
+                  </a:txBody>
+                  <a:tcPr marL="82296" marR="82296" marT="82296" marB="82296" anchor="ctr">
+                    <a:lnL w="6350" cap="flat" cmpd="sng" algn="ctr">
+                      <a:solidFill>
+                        <a:srgbClr val="D7E0DE"/>
+                      </a:solidFill>
+                      <a:prstDash val="solid"/>
+                      <a:round/>
+                      <a:headEnd type="none" w="med" len="med"/>
+                      <a:tailEnd type="none" w="med" len="med"/>
+                    </a:lnL>
+                    <a:lnR w="6350" cap="flat" cmpd="sng" algn="ctr">
+                      <a:solidFill>
+                        <a:srgbClr val="D7E0DE"/>
+                      </a:solidFill>
+                      <a:prstDash val="solid"/>
+                      <a:round/>
+                      <a:headEnd type="none" w="med" len="med"/>
+                      <a:tailEnd type="none" w="med" len="med"/>
+                    </a:lnR>
+                    <a:lnT w="6350" cap="flat" cmpd="sng" algn="ctr">
+                      <a:solidFill>
+                        <a:srgbClr val="D7E0DE"/>
+                      </a:solidFill>
+                      <a:prstDash val="solid"/>
+                      <a:round/>
+                      <a:headEnd type="none" w="med" len="med"/>
+                      <a:tailEnd type="none" w="med" len="med"/>
+                    </a:lnT>
+                    <a:lnB w="6350" cap="flat" cmpd="sng" algn="ctr">
+                      <a:solidFill>
+                        <a:srgbClr val="D7E0DE"/>
+                      </a:solidFill>
+                      <a:prstDash val="solid"/>
+                      <a:round/>
+                      <a:headEnd type="none" w="med" len="med"/>
+                      <a:tailEnd type="none" w="med" len="med"/>
+                    </a:lnB>
+                    <a:solidFill>
+                      <a:srgbClr val="FFFFFF"/>
+                    </a:solidFill>
+                  </a:tcPr>
+                </a:tc>
+                <a:tc>
+                  <a:txBody>
+                    <a:bodyPr/>
+                    <a:lstStyle/>
+                    <a:p>
+                      <a:pPr indent="0" marL="0">
+                        <a:buNone/>
+                      </a:pPr>
+                      <a:r>
+                        <a:rPr lang="en-US" sz="1400" dirty="0">
+                          <a:solidFill>
+                            <a:srgbClr val="172D30"/>
+                          </a:solidFill>
+                          <a:latin typeface="Arial" pitchFamily="34" charset="0"/>
+                          <a:ea typeface="Arial" pitchFamily="34" charset="-122"/>
+                          <a:cs typeface="Arial" pitchFamily="34" charset="-120"/>
+                        </a:rPr>
+                        <a:t>Traces, checkpoints, manifests, plots</a:t>
+                      </a:r>
+                      <a:endParaRPr lang="en-US" sz="1400" dirty="0">
+                        <a:latin typeface="Arial" charset="0"/>
+                        <a:ea typeface="Arial" charset="0"/>
+                        <a:cs typeface="Arial" charset="0"/>
+                      </a:endParaRPr>
+                    </a:p>
+                  </a:txBody>
+                  <a:tcPr marL="82296" marR="82296" marT="82296" marB="82296" anchor="ctr">
+                    <a:lnL w="6350" cap="flat" cmpd="sng" algn="ctr">
+                      <a:solidFill>
+                        <a:srgbClr val="D7E0DE"/>
+                      </a:solidFill>
+                      <a:prstDash val="solid"/>
+                      <a:round/>
+                      <a:headEnd type="none" w="med" len="med"/>
+                      <a:tailEnd type="none" w="med" len="med"/>
+                    </a:lnL>
+                    <a:lnR w="6350" cap="flat" cmpd="sng" algn="ctr">
+                      <a:solidFill>
+                        <a:srgbClr val="D7E0DE"/>
+                      </a:solidFill>
+                      <a:prstDash val="solid"/>
+                      <a:round/>
+                      <a:headEnd type="none" w="med" len="med"/>
+                      <a:tailEnd type="none" w="med" len="med"/>
+                    </a:lnR>
+                    <a:lnT w="6350" cap="flat" cmpd="sng" algn="ctr">
+                      <a:solidFill>
+                        <a:srgbClr val="D7E0DE"/>
+                      </a:solidFill>
+                      <a:prstDash val="solid"/>
+                      <a:round/>
+                      <a:headEnd type="none" w="med" len="med"/>
+                      <a:tailEnd type="none" w="med" len="med"/>
+                    </a:lnT>
+                    <a:lnB w="6350" cap="flat" cmpd="sng" algn="ctr">
+                      <a:solidFill>
+                        <a:srgbClr val="D7E0DE"/>
+                      </a:solidFill>
+                      <a:prstDash val="solid"/>
+                      <a:round/>
+                      <a:headEnd type="none" w="med" len="med"/>
+                      <a:tailEnd type="none" w="med" len="med"/>
+                    </a:lnB>
+                    <a:solidFill>
+                      <a:srgbClr val="FFFFFF"/>
+                    </a:solidFill>
+                  </a:tcPr>
+                </a:tc>
+              </a:tr>
+              <a:tr h="438912">
+                <a:tc>
+                  <a:txBody>
+                    <a:bodyPr/>
+                    <a:lstStyle/>
+                    <a:p>
+                      <a:pPr indent="0" marL="0">
+                        <a:buNone/>
+                      </a:pPr>
+                      <a:r>
+                        <a:rPr lang="en-US" sz="1400" dirty="0">
+                          <a:solidFill>
+                            <a:srgbClr val="172D30"/>
+                          </a:solidFill>
+                          <a:latin typeface="Arial" pitchFamily="34" charset="0"/>
+                          <a:ea typeface="Arial" pitchFamily="34" charset="-122"/>
+                          <a:cs typeface="Arial" pitchFamily="34" charset="-120"/>
+                        </a:rPr>
+                        <a:t>Shared core</a:t>
+                      </a:r>
+                      <a:endParaRPr lang="en-US" sz="1400" dirty="0">
+                        <a:latin typeface="Arial" charset="0"/>
+                        <a:ea typeface="Arial" charset="0"/>
+                        <a:cs typeface="Arial" charset="0"/>
+                      </a:endParaRPr>
+                    </a:p>
+                  </a:txBody>
+                  <a:tcPr marL="82296" marR="82296" marT="82296" marB="82296" anchor="ctr">
+                    <a:lnL w="6350" cap="flat" cmpd="sng" algn="ctr">
+                      <a:solidFill>
+                        <a:srgbClr val="D7E0DE"/>
+                      </a:solidFill>
+                      <a:prstDash val="solid"/>
+                      <a:round/>
+                      <a:headEnd type="none" w="med" len="med"/>
+                      <a:tailEnd type="none" w="med" len="med"/>
+                    </a:lnL>
+                    <a:lnR w="6350" cap="flat" cmpd="sng" algn="ctr">
+                      <a:solidFill>
+                        <a:srgbClr val="D7E0DE"/>
+                      </a:solidFill>
+                      <a:prstDash val="solid"/>
+                      <a:round/>
+                      <a:headEnd type="none" w="med" len="med"/>
+                      <a:tailEnd type="none" w="med" len="med"/>
+                    </a:lnR>
+                    <a:lnT w="6350" cap="flat" cmpd="sng" algn="ctr">
+                      <a:solidFill>
+                        <a:srgbClr val="D7E0DE"/>
+                      </a:solidFill>
+                      <a:prstDash val="solid"/>
+                      <a:round/>
+                      <a:headEnd type="none" w="med" len="med"/>
+                      <a:tailEnd type="none" w="med" len="med"/>
+                    </a:lnT>
+                    <a:lnB w="6350" cap="flat" cmpd="sng" algn="ctr">
+                      <a:solidFill>
+                        <a:srgbClr val="D7E0DE"/>
+                      </a:solidFill>
+                      <a:prstDash val="solid"/>
+                      <a:round/>
+                      <a:headEnd type="none" w="med" len="med"/>
+                      <a:tailEnd type="none" w="med" len="med"/>
+                    </a:lnB>
+                    <a:solidFill>
+                      <a:srgbClr val="FFFFFF"/>
+                    </a:solidFill>
+                  </a:tcPr>
+                </a:tc>
+                <a:tc>
+                  <a:txBody>
+                    <a:bodyPr/>
+                    <a:lstStyle/>
+                    <a:p>
+                      <a:pPr indent="0" marL="0">
+                        <a:buNone/>
+                      </a:pPr>
+                      <a:r>
+                        <a:rPr lang="en-US" sz="1400" dirty="0">
+                          <a:solidFill>
+                            <a:srgbClr val="172D30"/>
+                          </a:solidFill>
+                          <a:latin typeface="Arial" pitchFamily="34" charset="0"/>
+                          <a:ea typeface="Arial" pitchFamily="34" charset="-122"/>
+                          <a:cs typeface="Arial" pitchFamily="34" charset="-120"/>
+                        </a:rPr>
+                        <a:t>Two detectors + synthetic data</a:t>
+                      </a:r>
+                      <a:endParaRPr lang="en-US" sz="1400" dirty="0">
+                        <a:latin typeface="Arial" charset="0"/>
+                        <a:ea typeface="Arial" charset="0"/>
+                        <a:cs typeface="Arial" charset="0"/>
+                      </a:endParaRPr>
+                    </a:p>
+                  </a:txBody>
+                  <a:tcPr marL="82296" marR="82296" marT="82296" marB="82296" anchor="ctr">
+                    <a:lnL w="6350" cap="flat" cmpd="sng" algn="ctr">
+                      <a:solidFill>
+                        <a:srgbClr val="D7E0DE"/>
+                      </a:solidFill>
+                      <a:prstDash val="solid"/>
+                      <a:round/>
+                      <a:headEnd type="none" w="med" len="med"/>
+                      <a:tailEnd type="none" w="med" len="med"/>
+                    </a:lnL>
+                    <a:lnR w="6350" cap="flat" cmpd="sng" algn="ctr">
+                      <a:solidFill>
+                        <a:srgbClr val="D7E0DE"/>
+                      </a:solidFill>
+                      <a:prstDash val="solid"/>
+                      <a:round/>
+                      <a:headEnd type="none" w="med" len="med"/>
+                      <a:tailEnd type="none" w="med" len="med"/>
+                    </a:lnR>
+                    <a:lnT w="6350" cap="flat" cmpd="sng" algn="ctr">
+                      <a:solidFill>
+                        <a:srgbClr val="D7E0DE"/>
+                      </a:solidFill>
+                      <a:prstDash val="solid"/>
+                      <a:round/>
+                      <a:headEnd type="none" w="med" len="med"/>
+                      <a:tailEnd type="none" w="med" len="med"/>
+                    </a:lnT>
+                    <a:lnB w="6350" cap="flat" cmpd="sng" algn="ctr">
+                      <a:solidFill>
+                        <a:srgbClr val="D7E0DE"/>
+                      </a:solidFill>
+                      <a:prstDash val="solid"/>
+                      <a:round/>
+                      <a:headEnd type="none" w="med" len="med"/>
+                      <a:tailEnd type="none" w="med" len="med"/>
+                    </a:lnB>
+                    <a:solidFill>
+                      <a:srgbClr val="FFFFFF"/>
+                    </a:solidFill>
+                  </a:tcPr>
+                </a:tc>
+                <a:tc>
+                  <a:txBody>
+                    <a:bodyPr/>
+                    <a:lstStyle/>
+                    <a:p>
+                      <a:pPr indent="0" marL="0">
+                        <a:buNone/>
+                      </a:pPr>
+                      <a:r>
+                        <a:rPr lang="en-US" sz="1400" dirty="0">
+                          <a:solidFill>
+                            <a:srgbClr val="172D30"/>
+                          </a:solidFill>
+                          <a:latin typeface="Arial" pitchFamily="34" charset="0"/>
+                          <a:ea typeface="Arial" pitchFamily="34" charset="-122"/>
+                          <a:cs typeface="Arial" pitchFamily="34" charset="-120"/>
+                        </a:rPr>
+                        <a:t>Same model/data bytes; architecture retained</a:t>
+                      </a:r>
+                      <a:endParaRPr lang="en-US" sz="1400" dirty="0">
+                        <a:latin typeface="Arial" charset="0"/>
+                        <a:ea typeface="Arial" charset="0"/>
+                        <a:cs typeface="Arial" charset="0"/>
+                      </a:endParaRPr>
+                    </a:p>
+                  </a:txBody>
+                  <a:tcPr marL="82296" marR="82296" marT="82296" marB="82296" anchor="ctr">
+                    <a:lnL w="6350" cap="flat" cmpd="sng" algn="ctr">
+                      <a:solidFill>
+                        <a:srgbClr val="D7E0DE"/>
+                      </a:solidFill>
+                      <a:prstDash val="solid"/>
+                      <a:round/>
+                      <a:headEnd type="none" w="med" len="med"/>
+                      <a:tailEnd type="none" w="med" len="med"/>
+                    </a:lnL>
+                    <a:lnR w="6350" cap="flat" cmpd="sng" algn="ctr">
+                      <a:solidFill>
+                        <a:srgbClr val="D7E0DE"/>
+                      </a:solidFill>
+                      <a:prstDash val="solid"/>
+                      <a:round/>
+                      <a:headEnd type="none" w="med" len="med"/>
+                      <a:tailEnd type="none" w="med" len="med"/>
+                    </a:lnR>
+                    <a:lnT w="6350" cap="flat" cmpd="sng" algn="ctr">
+                      <a:solidFill>
+                        <a:srgbClr val="D7E0DE"/>
+                      </a:solidFill>
+                      <a:prstDash val="solid"/>
+                      <a:round/>
+                      <a:headEnd type="none" w="med" len="med"/>
+                      <a:tailEnd type="none" w="med" len="med"/>
+                    </a:lnT>
+                    <a:lnB w="6350" cap="flat" cmpd="sng" algn="ctr">
+                      <a:solidFill>
+                        <a:srgbClr val="D7E0DE"/>
+                      </a:solidFill>
+                      <a:prstDash val="solid"/>
+                      <a:round/>
+                      <a:headEnd type="none" w="med" len="med"/>
+                      <a:tailEnd type="none" w="med" len="med"/>
+                    </a:lnB>
+                    <a:solidFill>
+                      <a:srgbClr val="FFFFFF"/>
+                    </a:solidFill>
+                  </a:tcPr>
+                </a:tc>
+              </a:tr>
+            </a:tbl>
+          </a:graphicData>
+        </a:graphic>
+      </p:graphicFrame>
+      <p:sp>
+        <p:nvSpPr>
+          <p:cNvPr id="8" name="Text 5"/>
+          <p:cNvSpPr/>
+          <p:nvPr/>
+        </p:nvSpPr>
+        <p:spPr>
+          <a:xfrm>
+            <a:off x="457200" y="3840480"/>
+            <a:ext cx="8229600" cy="274320"/>
+          </a:xfrm>
+          <a:prstGeom prst="rect">
+            <a:avLst/>
+          </a:prstGeom>
+          <a:noFill/>
+          <a:ln/>
+        </p:spPr>
+        <p:txBody>
+          <a:bodyPr wrap="square" lIns="0" tIns="0" rIns="0" bIns="0" rtlCol="0" anchor="t"/>
+          <a:lstStyle/>
+          <a:p>
+            <a:pPr indent="0" marL="0">
+              <a:buNone/>
+            </a:pPr>
+            <a:r>
+              <a:rPr lang="en-US" sz="1500" b="1" dirty="0">
                 <a:solidFill>
                   <a:srgbClr val="01696F"/>
                 </a:solidFill>
@@ -6364,312 +7926,9 @@
                 <a:ea typeface="Arial" pitchFamily="34" charset="-122"/>
                 <a:cs typeface="Arial" pitchFamily="34" charset="-120"/>
               </a:rPr>
-              <a:t>Implemented</a:t>
-            </a:r>
-            <a:endParaRPr lang="en-US" sz="2000" dirty="0"/>
-          </a:p>
-        </p:txBody>
-      </p:sp>
-      <p:sp>
-        <p:nvSpPr>
-          <p:cNvPr id="8" name="Text 6"/>
-          <p:cNvSpPr/>
-          <p:nvPr/>
-        </p:nvSpPr>
-        <p:spPr>
-          <a:xfrm>
-            <a:off x="2834640" y="1371600"/>
-            <a:ext cx="5852160" cy="594360"/>
-          </a:xfrm>
-          <a:prstGeom prst="rect">
-            <a:avLst/>
-          </a:prstGeom>
-          <a:noFill/>
-          <a:ln/>
-        </p:spPr>
-        <p:txBody>
-          <a:bodyPr wrap="square" lIns="0" tIns="0" rIns="0" bIns="0" rtlCol="0" anchor="t"/>
-          <a:lstStyle/>
-          <a:p>
-            <a:pPr indent="0" marL="0">
-              <a:buNone/>
-            </a:pPr>
-            <a:r>
-              <a:rPr lang="en-US" sz="1700" dirty="0">
-                <a:solidFill>
-                  <a:srgbClr val="202B2D"/>
-                </a:solidFill>
-                <a:latin typeface="Arial" pitchFamily="34" charset="0"/>
-                <a:ea typeface="Arial" pitchFamily="34" charset="-122"/>
-                <a:cs typeface="Arial" pitchFamily="34" charset="-120"/>
-              </a:rPr>
-              <a:t>Campaign simulation, two detectors,</a:t>
-            </a:r>
-            <a:endParaRPr lang="en-US" sz="1700" dirty="0"/>
-          </a:p>
-          <a:p>
-            <a:pPr indent="0" marL="0">
-              <a:buNone/>
-            </a:pPr>
-            <a:r>
-              <a:rPr lang="en-US" sz="1700" dirty="0">
-                <a:solidFill>
-                  <a:srgbClr val="202B2D"/>
-                </a:solidFill>
-                <a:latin typeface="Arial" pitchFamily="34" charset="0"/>
-                <a:ea typeface="Arial" pitchFamily="34" charset="-122"/>
-                <a:cs typeface="Arial" pitchFamily="34" charset="-120"/>
-              </a:rPr>
-              <a:t>four attacker controls and raw outputs.</a:t>
-            </a:r>
-            <a:endParaRPr lang="en-US" sz="1700" dirty="0"/>
-          </a:p>
-        </p:txBody>
-      </p:sp>
-      <p:sp>
-        <p:nvSpPr>
-          <p:cNvPr id="9" name="Text 7"/>
-          <p:cNvSpPr/>
-          <p:nvPr/>
-        </p:nvSpPr>
-        <p:spPr>
-          <a:xfrm>
-            <a:off x="457200" y="2194560"/>
-            <a:ext cx="2286000" cy="365760"/>
-          </a:xfrm>
-          <a:prstGeom prst="rect">
-            <a:avLst/>
-          </a:prstGeom>
-          <a:noFill/>
-          <a:ln/>
-        </p:spPr>
-        <p:txBody>
-          <a:bodyPr wrap="square" lIns="0" tIns="0" rIns="0" bIns="0" rtlCol="0" anchor="t"/>
-          <a:lstStyle/>
-          <a:p>
-            <a:pPr indent="0" marL="0">
-              <a:buNone/>
-            </a:pPr>
-            <a:r>
-              <a:rPr lang="en-US" sz="2000" b="1" dirty="0">
-                <a:solidFill>
-                  <a:srgbClr val="01696F"/>
-                </a:solidFill>
-                <a:latin typeface="Arial" pitchFamily="34" charset="0"/>
-                <a:ea typeface="Arial" pitchFamily="34" charset="-122"/>
-                <a:cs typeface="Arial" pitchFamily="34" charset="-120"/>
-              </a:rPr>
-              <a:t>Still limited</a:t>
-            </a:r>
-            <a:endParaRPr lang="en-US" sz="2000" dirty="0"/>
-          </a:p>
-        </p:txBody>
-      </p:sp>
-      <p:sp>
-        <p:nvSpPr>
-          <p:cNvPr id="10" name="Text 8"/>
-          <p:cNvSpPr/>
-          <p:nvPr/>
-        </p:nvSpPr>
-        <p:spPr>
-          <a:xfrm>
-            <a:off x="2834640" y="2194560"/>
-            <a:ext cx="5852160" cy="594360"/>
-          </a:xfrm>
-          <a:prstGeom prst="rect">
-            <a:avLst/>
-          </a:prstGeom>
-          <a:noFill/>
-          <a:ln/>
-        </p:spPr>
-        <p:txBody>
-          <a:bodyPr wrap="square" lIns="0" tIns="0" rIns="0" bIns="0" rtlCol="0" anchor="t"/>
-          <a:lstStyle/>
-          <a:p>
-            <a:pPr indent="0" marL="0">
-              <a:buNone/>
-            </a:pPr>
-            <a:r>
-              <a:rPr lang="en-US" sz="1700" dirty="0">
-                <a:solidFill>
-                  <a:srgbClr val="202B2D"/>
-                </a:solidFill>
-                <a:latin typeface="Arial" pitchFamily="34" charset="0"/>
-                <a:ea typeface="Arial" pitchFamily="34" charset="-122"/>
-                <a:cs typeface="Arial" pitchFamily="34" charset="-120"/>
-              </a:rPr>
-              <a:t>Synthetic data; detector-family exclusion</a:t>
-            </a:r>
-            <a:endParaRPr lang="en-US" sz="1700" dirty="0"/>
-          </a:p>
-          <a:p>
-            <a:pPr indent="0" marL="0">
-              <a:buNone/>
-            </a:pPr>
-            <a:r>
-              <a:rPr lang="en-US" sz="1700" dirty="0">
-                <a:solidFill>
-                  <a:srgbClr val="202B2D"/>
-                </a:solidFill>
-                <a:latin typeface="Arial" pitchFamily="34" charset="0"/>
-                <a:ea typeface="Arial" pitchFamily="34" charset="-122"/>
-                <a:cs typeface="Arial" pitchFamily="34" charset="-120"/>
-              </a:rPr>
-              <a:t>unverified; legacy policy comparisons confounded.</a:t>
-            </a:r>
-            <a:endParaRPr lang="en-US" sz="1700" dirty="0"/>
-          </a:p>
-        </p:txBody>
-      </p:sp>
-      <p:sp>
-        <p:nvSpPr>
-          <p:cNvPr id="11" name="Text 9"/>
-          <p:cNvSpPr/>
-          <p:nvPr/>
-        </p:nvSpPr>
-        <p:spPr>
-          <a:xfrm>
-            <a:off x="457200" y="3017520"/>
-            <a:ext cx="2286000" cy="365760"/>
-          </a:xfrm>
-          <a:prstGeom prst="rect">
-            <a:avLst/>
-          </a:prstGeom>
-          <a:noFill/>
-          <a:ln/>
-        </p:spPr>
-        <p:txBody>
-          <a:bodyPr wrap="square" lIns="0" tIns="0" rIns="0" bIns="0" rtlCol="0" anchor="t"/>
-          <a:lstStyle/>
-          <a:p>
-            <a:pPr indent="0" marL="0">
-              <a:buNone/>
-            </a:pPr>
-            <a:r>
-              <a:rPr lang="en-US" sz="2000" b="1" dirty="0">
-                <a:solidFill>
-                  <a:srgbClr val="01696F"/>
-                </a:solidFill>
-                <a:latin typeface="Arial" pitchFamily="34" charset="0"/>
-                <a:ea typeface="Arial" pitchFamily="34" charset="-122"/>
-                <a:cs typeface="Arial" pitchFamily="34" charset="-120"/>
-              </a:rPr>
-              <a:t>Submission pending</a:t>
-            </a:r>
-            <a:endParaRPr lang="en-US" sz="2000" dirty="0"/>
-          </a:p>
-        </p:txBody>
-      </p:sp>
-      <p:sp>
-        <p:nvSpPr>
-          <p:cNvPr id="12" name="Text 10"/>
-          <p:cNvSpPr/>
-          <p:nvPr/>
-        </p:nvSpPr>
-        <p:spPr>
-          <a:xfrm>
-            <a:off x="2834640" y="3017520"/>
-            <a:ext cx="5852160" cy="594360"/>
-          </a:xfrm>
-          <a:prstGeom prst="rect">
-            <a:avLst/>
-          </a:prstGeom>
-          <a:noFill/>
-          <a:ln/>
-        </p:spPr>
-        <p:txBody>
-          <a:bodyPr wrap="square" lIns="0" tIns="0" rIns="0" bIns="0" rtlCol="0" anchor="t"/>
-          <a:lstStyle/>
-          <a:p>
-            <a:pPr indent="0" marL="0">
-              <a:buNone/>
-            </a:pPr>
-            <a:r>
-              <a:rPr lang="en-US" sz="1700" dirty="0">
-                <a:solidFill>
-                  <a:srgbClr val="202B2D"/>
-                </a:solidFill>
-                <a:latin typeface="Arial" pitchFamily="34" charset="0"/>
-                <a:ea typeface="Arial" pitchFamily="34" charset="-122"/>
-                <a:cs typeface="Arial" pitchFamily="34" charset="-120"/>
-              </a:rPr>
-              <a:t>The later IEEE draft is AI-assisted.</a:t>
-            </a:r>
-            <a:endParaRPr lang="en-US" sz="1700" dirty="0"/>
-          </a:p>
-          <a:p>
-            <a:pPr indent="0" marL="0">
-              <a:buNone/>
-            </a:pPr>
-            <a:r>
-              <a:rPr lang="en-US" sz="1700" dirty="0">
-                <a:solidFill>
-                  <a:srgbClr val="202B2D"/>
-                </a:solidFill>
-                <a:latin typeface="Arial" pitchFamily="34" charset="0"/>
-                <a:ea typeface="Arial" pitchFamily="34" charset="-122"/>
-                <a:cs typeface="Arial" pitchFamily="34" charset="-120"/>
-              </a:rPr>
-              <a:t>Human authorship review and approved checks remain.</a:t>
-            </a:r>
-            <a:endParaRPr lang="en-US" sz="1700" dirty="0"/>
-          </a:p>
-        </p:txBody>
-      </p:sp>
-      <p:sp>
-        <p:nvSpPr>
-          <p:cNvPr id="13" name="Text 11"/>
-          <p:cNvSpPr/>
-          <p:nvPr/>
-        </p:nvSpPr>
-        <p:spPr>
-          <a:xfrm>
-            <a:off x="457200" y="4023360"/>
-            <a:ext cx="8229600" cy="274320"/>
-          </a:xfrm>
-          <a:prstGeom prst="rect">
-            <a:avLst/>
-          </a:prstGeom>
-          <a:noFill/>
-          <a:ln/>
-        </p:spPr>
-        <p:txBody>
-          <a:bodyPr wrap="square" lIns="0" tIns="0" rIns="0" bIns="0" rtlCol="0" anchor="ctr"/>
-          <a:lstStyle/>
-          <a:p>
-            <a:pPr indent="0" marL="0">
-              <a:buNone/>
-            </a:pPr>
-            <a:r>
-              <a:rPr lang="en-US" sz="1300" dirty="0">
-                <a:solidFill>
-                  <a:srgbClr val="172D30"/>
-                </a:solidFill>
-                <a:latin typeface="Arial" pitchFamily="34" charset="0"/>
-                <a:ea typeface="Arial" pitchFamily="34" charset="-122"/>
-                <a:cs typeface="Arial" pitchFamily="34" charset="-120"/>
-              </a:rPr>
-              <a:t>Later dashboard, matched pilot and IEEE paper: </a:t>
-            </a:r>
-            <a:r>
-              <a:rPr lang="en-US" sz="1300" u="sng" dirty="0">
-                <a:solidFill>
-                  <a:srgbClr val="01696F"/>
-                </a:solidFill>
-                <a:latin typeface="Arial" pitchFamily="34" charset="0"/>
-                <a:ea typeface="Arial" pitchFamily="34" charset="-122"/>
-                <a:cs typeface="Arial" pitchFamily="34" charset="-120"/>
-                <a:hlinkClick r:id="rId2" invalidUrl="" action="" tgtFrame="" tooltip="" history="1" highlightClick="0" endSnd="0">
-                  <a:extLst>
-                    <a:ext uri="{A12FA001-AC4F-418D-AE19-62706E023703}">
-                      <ahyp:hlinkClr xmlns:ahyp="http://schemas.microsoft.com/office/drawing/2018/hyperlinkcolor" val="tx"/>
-                    </a:ext>
-                  </a:extLst>
-                </a:hlinkClick>
-              </a:rPr>
-              <a:t>review branch</a:t>
-            </a:r>
-            <a:endParaRPr lang="en-US" sz="1300" dirty="0"/>
+              <a:t>Engineering contribution, not a controlled performance comparison.</a:t>
+            </a:r>
+            <a:endParaRPr lang="en-US" sz="1500" dirty="0"/>
           </a:p>
         </p:txBody>
       </p:sp>

</xml_diff>